<commit_message>
Add full facilitator-script presenter notes to Emotions and Needs/Desires decks
Presenter notes (full say-this scripts, timings, breakout instructions) added to
Master Your Emotions (32), Coming Home to Yourself (22), Speaking It So You're
Heard (17). Includes add_notes_others.py to re-apply after regeneration.

Co-Authored-By: Claude Opus 4.8 <noreply@anthropic.com>
Claude-Session: https://claude.ai/code/session_01FhNN1xnUyELSQ3xs2X22yA
</commit_message>
<xml_diff>
--- a/content/sessions/slides/Master-Your-Emotions.pptx
+++ b/content/sessions/slides/Master-Your-Emotions.pptx
@@ -136,6 +136,2596 @@
     </a:lvl9pPr>
   </p:defaultTextStyle>
 </p:presentation>
+</file>
+
+<file path=ppt/notesMasters/notesMaster1.xml><?xml version="1.0" encoding="utf-8"?>
+<p:notesMaster xmlns:a="http://schemas.openxmlformats.org/drawingml/2006/main" xmlns:p="http://schemas.openxmlformats.org/presentationml/2006/main" xmlns:r="http://schemas.openxmlformats.org/officeDocument/2006/relationships">
+  <p:cSld>
+    <p:bg>
+      <p:bgRef idx="1001">
+        <a:schemeClr val="bg1"/>
+      </p:bgRef>
+    </p:bg>
+    <p:spTree>
+      <p:nvGrpSpPr>
+        <p:cNvPr id="1" name=""/>
+        <p:cNvGrpSpPr/>
+        <p:nvPr/>
+      </p:nvGrpSpPr>
+      <p:grpSpPr>
+        <a:xfrm>
+          <a:off x="0" y="0"/>
+          <a:ext cx="0" cy="0"/>
+          <a:chOff x="0" y="0"/>
+          <a:chExt cx="0" cy="0"/>
+        </a:xfrm>
+      </p:grpSpPr>
+      <p:sp>
+        <p:nvSpPr>
+          <p:cNvPr id="2" name="Header Placeholder 1"/>
+          <p:cNvSpPr>
+            <a:spLocks noGrp="1"/>
+          </p:cNvSpPr>
+          <p:nvPr>
+            <p:ph type="hdr" sz="quarter"/>
+          </p:nvPr>
+        </p:nvSpPr>
+        <p:spPr>
+          <a:xfrm>
+            <a:off x="0" y="0"/>
+            <a:ext cx="2971800" cy="457200"/>
+          </a:xfrm>
+          <a:prstGeom prst="rect">
+            <a:avLst/>
+          </a:prstGeom>
+        </p:spPr>
+        <p:txBody>
+          <a:bodyPr vert="horz" lIns="91440" tIns="45720" rIns="91440" bIns="45720" rtlCol="0"/>
+          <a:lstStyle>
+            <a:lvl1pPr algn="l">
+              <a:defRPr sz="1200"/>
+            </a:lvl1pPr>
+          </a:lstStyle>
+          <a:p>
+            <a:endParaRPr lang="en-US"/>
+          </a:p>
+        </p:txBody>
+      </p:sp>
+      <p:sp>
+        <p:nvSpPr>
+          <p:cNvPr id="3" name="Date Placeholder 2"/>
+          <p:cNvSpPr>
+            <a:spLocks noGrp="1"/>
+          </p:cNvSpPr>
+          <p:nvPr>
+            <p:ph type="dt" idx="1"/>
+          </p:nvPr>
+        </p:nvSpPr>
+        <p:spPr>
+          <a:xfrm>
+            <a:off x="3884613" y="0"/>
+            <a:ext cx="2971800" cy="457200"/>
+          </a:xfrm>
+          <a:prstGeom prst="rect">
+            <a:avLst/>
+          </a:prstGeom>
+        </p:spPr>
+        <p:txBody>
+          <a:bodyPr vert="horz" lIns="91440" tIns="45720" rIns="91440" bIns="45720" rtlCol="0"/>
+          <a:lstStyle>
+            <a:lvl1pPr algn="r">
+              <a:defRPr sz="1200"/>
+            </a:lvl1pPr>
+          </a:lstStyle>
+          <a:p>
+            <a:fld id="{0F89C1C7-3DCD-1040-A9CF-14679D8B5DDD}" type="datetimeFigureOut">
+              <a:rPr lang="en-US" smtClean="0"/>
+              <a:t>10/17/16</a:t>
+            </a:fld>
+            <a:endParaRPr lang="en-US"/>
+          </a:p>
+        </p:txBody>
+      </p:sp>
+      <p:sp>
+        <p:nvSpPr>
+          <p:cNvPr id="4" name="Slide Image Placeholder 3"/>
+          <p:cNvSpPr>
+            <a:spLocks noGrp="1" noRot="1" noChangeAspect="1"/>
+          </p:cNvSpPr>
+          <p:nvPr>
+            <p:ph type="sldImg" idx="2"/>
+          </p:nvPr>
+        </p:nvSpPr>
+        <p:spPr>
+          <a:xfrm>
+            <a:off x="1143000" y="685800"/>
+            <a:ext cx="4572000" cy="3429000"/>
+          </a:xfrm>
+          <a:prstGeom prst="rect">
+            <a:avLst/>
+          </a:prstGeom>
+          <a:noFill/>
+          <a:ln w="12700">
+            <a:solidFill>
+              <a:prstClr val="black"/>
+            </a:solidFill>
+          </a:ln>
+        </p:spPr>
+        <p:txBody>
+          <a:bodyPr vert="horz" lIns="91440" tIns="45720" rIns="91440" bIns="45720" rtlCol="0" anchor="ctr"/>
+          <a:lstStyle/>
+          <a:p>
+            <a:endParaRPr lang="en-US"/>
+          </a:p>
+        </p:txBody>
+      </p:sp>
+      <p:sp>
+        <p:nvSpPr>
+          <p:cNvPr id="5" name="Notes Placeholder 4"/>
+          <p:cNvSpPr>
+            <a:spLocks noGrp="1"/>
+          </p:cNvSpPr>
+          <p:nvPr>
+            <p:ph type="body" sz="quarter" idx="3"/>
+          </p:nvPr>
+        </p:nvSpPr>
+        <p:spPr>
+          <a:xfrm>
+            <a:off x="685800" y="4343400"/>
+            <a:ext cx="5486400" cy="4114800"/>
+          </a:xfrm>
+          <a:prstGeom prst="rect">
+            <a:avLst/>
+          </a:prstGeom>
+        </p:spPr>
+        <p:txBody>
+          <a:bodyPr vert="horz" lIns="91440" tIns="45720" rIns="91440" bIns="45720" rtlCol="0"/>
+          <a:lstStyle/>
+          <a:p>
+            <a:pPr lvl="0"/>
+            <a:r>
+              <a:rPr lang="en-US" smtClean="0"/>
+              <a:t>Click to edit Master text styles</a:t>
+            </a:r>
+          </a:p>
+          <a:p>
+            <a:pPr lvl="1"/>
+            <a:r>
+              <a:rPr lang="en-US" smtClean="0"/>
+              <a:t>Second level</a:t>
+            </a:r>
+          </a:p>
+          <a:p>
+            <a:pPr lvl="2"/>
+            <a:r>
+              <a:rPr lang="en-US" smtClean="0"/>
+              <a:t>Third level</a:t>
+            </a:r>
+          </a:p>
+          <a:p>
+            <a:pPr lvl="3"/>
+            <a:r>
+              <a:rPr lang="en-US" smtClean="0"/>
+              <a:t>Fourth level</a:t>
+            </a:r>
+          </a:p>
+          <a:p>
+            <a:pPr lvl="4"/>
+            <a:r>
+              <a:rPr lang="en-US" smtClean="0"/>
+              <a:t>Fifth level</a:t>
+            </a:r>
+            <a:endParaRPr lang="en-US"/>
+          </a:p>
+        </p:txBody>
+      </p:sp>
+      <p:sp>
+        <p:nvSpPr>
+          <p:cNvPr id="6" name="Footer Placeholder 5"/>
+          <p:cNvSpPr>
+            <a:spLocks noGrp="1"/>
+          </p:cNvSpPr>
+          <p:nvPr>
+            <p:ph type="ftr" sz="quarter" idx="4"/>
+          </p:nvPr>
+        </p:nvSpPr>
+        <p:spPr>
+          <a:xfrm>
+            <a:off x="0" y="8685213"/>
+            <a:ext cx="2971800" cy="457200"/>
+          </a:xfrm>
+          <a:prstGeom prst="rect">
+            <a:avLst/>
+          </a:prstGeom>
+        </p:spPr>
+        <p:txBody>
+          <a:bodyPr vert="horz" lIns="91440" tIns="45720" rIns="91440" bIns="45720" rtlCol="0" anchor="b"/>
+          <a:lstStyle>
+            <a:lvl1pPr algn="l">
+              <a:defRPr sz="1200"/>
+            </a:lvl1pPr>
+          </a:lstStyle>
+          <a:p>
+            <a:endParaRPr lang="en-US"/>
+          </a:p>
+        </p:txBody>
+      </p:sp>
+      <p:sp>
+        <p:nvSpPr>
+          <p:cNvPr id="7" name="Slide Number Placeholder 6"/>
+          <p:cNvSpPr>
+            <a:spLocks noGrp="1"/>
+          </p:cNvSpPr>
+          <p:nvPr>
+            <p:ph type="sldNum" sz="quarter" idx="5"/>
+          </p:nvPr>
+        </p:nvSpPr>
+        <p:spPr>
+          <a:xfrm>
+            <a:off x="3884613" y="8685213"/>
+            <a:ext cx="2971800" cy="457200"/>
+          </a:xfrm>
+          <a:prstGeom prst="rect">
+            <a:avLst/>
+          </a:prstGeom>
+        </p:spPr>
+        <p:txBody>
+          <a:bodyPr vert="horz" lIns="91440" tIns="45720" rIns="91440" bIns="45720" rtlCol="0" anchor="b"/>
+          <a:lstStyle>
+            <a:lvl1pPr algn="r">
+              <a:defRPr sz="1200"/>
+            </a:lvl1pPr>
+          </a:lstStyle>
+          <a:p>
+            <a:fld id="{BB5E49A5-4136-284D-997B-48E1D791AD67}" type="slidenum">
+              <a:rPr lang="en-US" smtClean="0"/>
+              <a:t>‹#›</a:t>
+            </a:fld>
+            <a:endParaRPr lang="en-US"/>
+          </a:p>
+        </p:txBody>
+      </p:sp>
+    </p:spTree>
+    <p:extLst>
+      <p:ext uri="{BB962C8B-B14F-4D97-AF65-F5344CB8AC3E}">
+        <p14:creationId xmlns:p14="http://schemas.microsoft.com/office/powerpoint/2010/main" val="2623252185"/>
+      </p:ext>
+    </p:extLst>
+  </p:cSld>
+  <p:clrMap bg1="lt1" tx1="dk1" bg2="lt2" tx2="dk2" accent1="accent1" accent2="accent2" accent3="accent3" accent4="accent4" accent5="accent5" accent6="accent6" hlink="hlink" folHlink="folHlink"/>
+  <p:notesStyle>
+    <a:lvl1pPr marL="0" algn="l" defTabSz="457200" rtl="0" eaLnBrk="1" latinLnBrk="0" hangingPunct="1">
+      <a:defRPr sz="1200" kern="1200">
+        <a:solidFill>
+          <a:schemeClr val="tx1"/>
+        </a:solidFill>
+        <a:latin typeface="+mn-lt"/>
+        <a:ea typeface="+mn-ea"/>
+        <a:cs typeface="+mn-cs"/>
+      </a:defRPr>
+    </a:lvl1pPr>
+    <a:lvl2pPr marL="457200" algn="l" defTabSz="457200" rtl="0" eaLnBrk="1" latinLnBrk="0" hangingPunct="1">
+      <a:defRPr sz="1200" kern="1200">
+        <a:solidFill>
+          <a:schemeClr val="tx1"/>
+        </a:solidFill>
+        <a:latin typeface="+mn-lt"/>
+        <a:ea typeface="+mn-ea"/>
+        <a:cs typeface="+mn-cs"/>
+      </a:defRPr>
+    </a:lvl2pPr>
+    <a:lvl3pPr marL="914400" algn="l" defTabSz="457200" rtl="0" eaLnBrk="1" latinLnBrk="0" hangingPunct="1">
+      <a:defRPr sz="1200" kern="1200">
+        <a:solidFill>
+          <a:schemeClr val="tx1"/>
+        </a:solidFill>
+        <a:latin typeface="+mn-lt"/>
+        <a:ea typeface="+mn-ea"/>
+        <a:cs typeface="+mn-cs"/>
+      </a:defRPr>
+    </a:lvl3pPr>
+    <a:lvl4pPr marL="1371600" algn="l" defTabSz="457200" rtl="0" eaLnBrk="1" latinLnBrk="0" hangingPunct="1">
+      <a:defRPr sz="1200" kern="1200">
+        <a:solidFill>
+          <a:schemeClr val="tx1"/>
+        </a:solidFill>
+        <a:latin typeface="+mn-lt"/>
+        <a:ea typeface="+mn-ea"/>
+        <a:cs typeface="+mn-cs"/>
+      </a:defRPr>
+    </a:lvl4pPr>
+    <a:lvl5pPr marL="1828800" algn="l" defTabSz="457200" rtl="0" eaLnBrk="1" latinLnBrk="0" hangingPunct="1">
+      <a:defRPr sz="1200" kern="1200">
+        <a:solidFill>
+          <a:schemeClr val="tx1"/>
+        </a:solidFill>
+        <a:latin typeface="+mn-lt"/>
+        <a:ea typeface="+mn-ea"/>
+        <a:cs typeface="+mn-cs"/>
+      </a:defRPr>
+    </a:lvl5pPr>
+    <a:lvl6pPr marL="2286000" algn="l" defTabSz="457200" rtl="0" eaLnBrk="1" latinLnBrk="0" hangingPunct="1">
+      <a:defRPr sz="1200" kern="1200">
+        <a:solidFill>
+          <a:schemeClr val="tx1"/>
+        </a:solidFill>
+        <a:latin typeface="+mn-lt"/>
+        <a:ea typeface="+mn-ea"/>
+        <a:cs typeface="+mn-cs"/>
+      </a:defRPr>
+    </a:lvl6pPr>
+    <a:lvl7pPr marL="2743200" algn="l" defTabSz="457200" rtl="0" eaLnBrk="1" latinLnBrk="0" hangingPunct="1">
+      <a:defRPr sz="1200" kern="1200">
+        <a:solidFill>
+          <a:schemeClr val="tx1"/>
+        </a:solidFill>
+        <a:latin typeface="+mn-lt"/>
+        <a:ea typeface="+mn-ea"/>
+        <a:cs typeface="+mn-cs"/>
+      </a:defRPr>
+    </a:lvl7pPr>
+    <a:lvl8pPr marL="3200400" algn="l" defTabSz="457200" rtl="0" eaLnBrk="1" latinLnBrk="0" hangingPunct="1">
+      <a:defRPr sz="1200" kern="1200">
+        <a:solidFill>
+          <a:schemeClr val="tx1"/>
+        </a:solidFill>
+        <a:latin typeface="+mn-lt"/>
+        <a:ea typeface="+mn-ea"/>
+        <a:cs typeface="+mn-cs"/>
+      </a:defRPr>
+    </a:lvl8pPr>
+    <a:lvl9pPr marL="3657600" algn="l" defTabSz="457200" rtl="0" eaLnBrk="1" latinLnBrk="0" hangingPunct="1">
+      <a:defRPr sz="1200" kern="1200">
+        <a:solidFill>
+          <a:schemeClr val="tx1"/>
+        </a:solidFill>
+        <a:latin typeface="+mn-lt"/>
+        <a:ea typeface="+mn-ea"/>
+        <a:cs typeface="+mn-cs"/>
+      </a:defRPr>
+    </a:lvl9pPr>
+  </p:notesStyle>
+</p:notesMaster>
+</file>
+
+<file path=ppt/notesSlides/notesSlide1.xml><?xml version="1.0" encoding="utf-8"?>
+<p:notes xmlns:a="http://schemas.openxmlformats.org/drawingml/2006/main" xmlns:p="http://schemas.openxmlformats.org/presentationml/2006/main" xmlns:r="http://schemas.openxmlformats.org/officeDocument/2006/relationships">
+  <p:cSld>
+    <p:spTree>
+      <p:nvGrpSpPr>
+        <p:cNvPr id="1" name=""/>
+        <p:cNvGrpSpPr/>
+        <p:nvPr/>
+      </p:nvGrpSpPr>
+      <p:grpSpPr>
+        <a:xfrm>
+          <a:off x="0" y="0"/>
+          <a:ext cx="0" cy="0"/>
+          <a:chOff x="0" y="0"/>
+          <a:chExt cx="0" cy="0"/>
+        </a:xfrm>
+      </p:grpSpPr>
+      <p:sp>
+        <p:nvSpPr>
+          <p:cNvPr id="2" name="Slide Image Placeholder 1"/>
+          <p:cNvSpPr>
+            <a:spLocks noGrp="1"/>
+          </p:cNvSpPr>
+          <p:nvPr>
+            <p:ph type="sldImg" idx="2"/>
+          </p:nvPr>
+        </p:nvSpPr>
+        <p:spPr/>
+      </p:sp>
+      <p:sp>
+        <p:nvSpPr>
+          <p:cNvPr id="3" name="Notes Placeholder 2"/>
+          <p:cNvSpPr>
+            <a:spLocks noGrp="1"/>
+          </p:cNvSpPr>
+          <p:nvPr>
+            <p:ph type="body" idx="3" sz="quarter"/>
+          </p:nvPr>
+        </p:nvSpPr>
+        <p:spPr/>
+        <p:txBody>
+          <a:bodyPr/>
+          <a:lstStyle/>
+          <a:p>
+            <a:r>
+              <a:t>Welcome. Light the candle, read the circle agreements: what's shared here stays here; we witness, we don't fix; you can always pass; there's no such thing as too much. Soften them in: feet on the floor, soften jaw, shoulders, belly, three slow breaths. 'Tonight we learn to be with our feelings, safely, not running and not drowning.' One-word go-round: how are you arriving?</a:t>
+            </a:r>
+          </a:p>
+        </p:txBody>
+      </p:sp>
+      <p:sp>
+        <p:nvSpPr>
+          <p:cNvPr id="4" name="Slide Number Placeholder 3"/>
+          <p:cNvSpPr>
+            <a:spLocks noGrp="1"/>
+          </p:cNvSpPr>
+          <p:nvPr>
+            <p:ph type="sldNum" idx="5" sz="quarter"/>
+          </p:nvPr>
+        </p:nvSpPr>
+        <p:spPr/>
+      </p:sp>
+    </p:spTree>
+  </p:cSld>
+  <p:clrMapOvr>
+    <a:masterClrMapping/>
+  </p:clrMapOvr>
+</p:notes>
+</file>
+
+<file path=ppt/notesSlides/notesSlide10.xml><?xml version="1.0" encoding="utf-8"?>
+<p:notes xmlns:a="http://schemas.openxmlformats.org/drawingml/2006/main" xmlns:p="http://schemas.openxmlformats.org/presentationml/2006/main" xmlns:r="http://schemas.openxmlformats.org/officeDocument/2006/relationships">
+  <p:cSld>
+    <p:spTree>
+      <p:nvGrpSpPr>
+        <p:cNvPr id="1" name=""/>
+        <p:cNvGrpSpPr/>
+        <p:nvPr/>
+      </p:nvGrpSpPr>
+      <p:grpSpPr>
+        <a:xfrm>
+          <a:off x="0" y="0"/>
+          <a:ext cx="0" cy="0"/>
+          <a:chOff x="0" y="0"/>
+          <a:chExt cx="0" cy="0"/>
+        </a:xfrm>
+      </p:grpSpPr>
+      <p:sp>
+        <p:nvSpPr>
+          <p:cNvPr id="2" name="Slide Image Placeholder 1"/>
+          <p:cNvSpPr>
+            <a:spLocks noGrp="1"/>
+          </p:cNvSpPr>
+          <p:nvPr>
+            <p:ph type="sldImg" idx="2"/>
+          </p:nvPr>
+        </p:nvSpPr>
+        <p:spPr/>
+      </p:sp>
+      <p:sp>
+        <p:nvSpPr>
+          <p:cNvPr id="3" name="Notes Placeholder 2"/>
+          <p:cNvSpPr>
+            <a:spLocks noGrp="1"/>
+          </p:cNvSpPr>
+          <p:nvPr>
+            <p:ph type="body" idx="3" sz="quarter"/>
+          </p:nvPr>
+        </p:nvSpPr>
+        <p:spPr/>
+        <p:txBody>
+          <a:bodyPr/>
+          <a:lstStyle/>
+          <a:p>
+            <a:r>
+              <a:t>Say it clearly: emotions are the messengers. Ignore them and they don't go away, they get louder, they start screaming until we listen. Numbing is what we do when we don't feel safe enough to feel, it's not a flaw.</a:t>
+            </a:r>
+          </a:p>
+        </p:txBody>
+      </p:sp>
+      <p:sp>
+        <p:nvSpPr>
+          <p:cNvPr id="4" name="Slide Number Placeholder 3"/>
+          <p:cNvSpPr>
+            <a:spLocks noGrp="1"/>
+          </p:cNvSpPr>
+          <p:nvPr>
+            <p:ph type="sldNum" idx="5" sz="quarter"/>
+          </p:nvPr>
+        </p:nvSpPr>
+        <p:spPr/>
+      </p:sp>
+    </p:spTree>
+  </p:cSld>
+  <p:clrMapOvr>
+    <a:masterClrMapping/>
+  </p:clrMapOvr>
+</p:notes>
+</file>
+
+<file path=ppt/notesSlides/notesSlide11.xml><?xml version="1.0" encoding="utf-8"?>
+<p:notes xmlns:a="http://schemas.openxmlformats.org/drawingml/2006/main" xmlns:p="http://schemas.openxmlformats.org/presentationml/2006/main" xmlns:r="http://schemas.openxmlformats.org/officeDocument/2006/relationships">
+  <p:cSld>
+    <p:spTree>
+      <p:nvGrpSpPr>
+        <p:cNvPr id="1" name=""/>
+        <p:cNvGrpSpPr/>
+        <p:nvPr/>
+      </p:nvGrpSpPr>
+      <p:grpSpPr>
+        <a:xfrm>
+          <a:off x="0" y="0"/>
+          <a:ext cx="0" cy="0"/>
+          <a:chOff x="0" y="0"/>
+          <a:chExt cx="0" cy="0"/>
+        </a:xfrm>
+      </p:grpSpPr>
+      <p:sp>
+        <p:nvSpPr>
+          <p:cNvPr id="2" name="Slide Image Placeholder 1"/>
+          <p:cNvSpPr>
+            <a:spLocks noGrp="1"/>
+          </p:cNvSpPr>
+          <p:nvPr>
+            <p:ph type="sldImg" idx="2"/>
+          </p:nvPr>
+        </p:nvSpPr>
+        <p:spPr/>
+      </p:sp>
+      <p:sp>
+        <p:nvSpPr>
+          <p:cNvPr id="3" name="Notes Placeholder 2"/>
+          <p:cNvSpPr>
+            <a:spLocks noGrp="1"/>
+          </p:cNvSpPr>
+          <p:nvPr>
+            <p:ph type="body" idx="3" sz="quarter"/>
+          </p:nvPr>
+        </p:nvSpPr>
+        <p:spPr/>
+        <p:txBody>
+          <a:bodyPr/>
+          <a:lstStyle/>
+          <a:p>
+            <a:r>
+              <a:t>One minute, soft music, journal: what do you reach for when a feeling gets too big? No judgement, just notice. Then: 'okay, completing this reflection.'</a:t>
+            </a:r>
+          </a:p>
+        </p:txBody>
+      </p:sp>
+      <p:sp>
+        <p:nvSpPr>
+          <p:cNvPr id="4" name="Slide Number Placeholder 3"/>
+          <p:cNvSpPr>
+            <a:spLocks noGrp="1"/>
+          </p:cNvSpPr>
+          <p:nvPr>
+            <p:ph type="sldNum" idx="5" sz="quarter"/>
+          </p:nvPr>
+        </p:nvSpPr>
+        <p:spPr/>
+      </p:sp>
+    </p:spTree>
+  </p:cSld>
+  <p:clrMapOvr>
+    <a:masterClrMapping/>
+  </p:clrMapOvr>
+</p:notes>
+</file>
+
+<file path=ppt/notesSlides/notesSlide12.xml><?xml version="1.0" encoding="utf-8"?>
+<p:notes xmlns:a="http://schemas.openxmlformats.org/drawingml/2006/main" xmlns:p="http://schemas.openxmlformats.org/presentationml/2006/main" xmlns:r="http://schemas.openxmlformats.org/officeDocument/2006/relationships">
+  <p:cSld>
+    <p:spTree>
+      <p:nvGrpSpPr>
+        <p:cNvPr id="1" name=""/>
+        <p:cNvGrpSpPr/>
+        <p:nvPr/>
+      </p:nvGrpSpPr>
+      <p:grpSpPr>
+        <a:xfrm>
+          <a:off x="0" y="0"/>
+          <a:ext cx="0" cy="0"/>
+          <a:chOff x="0" y="0"/>
+          <a:chExt cx="0" cy="0"/>
+        </a:xfrm>
+      </p:grpSpPr>
+      <p:sp>
+        <p:nvSpPr>
+          <p:cNvPr id="2" name="Slide Image Placeholder 1"/>
+          <p:cNvSpPr>
+            <a:spLocks noGrp="1"/>
+          </p:cNvSpPr>
+          <p:nvPr>
+            <p:ph type="sldImg" idx="2"/>
+          </p:nvPr>
+        </p:nvSpPr>
+        <p:spPr/>
+      </p:sp>
+      <p:sp>
+        <p:nvSpPr>
+          <p:cNvPr id="3" name="Notes Placeholder 2"/>
+          <p:cNvSpPr>
+            <a:spLocks noGrp="1"/>
+          </p:cNvSpPr>
+          <p:nvPr>
+            <p:ph type="body" idx="3" sz="quarter"/>
+          </p:nvPr>
+        </p:nvSpPr>
+        <p:spPr/>
+        <p:txBody>
+          <a:bodyPr/>
+          <a:lstStyle/>
+          <a:p>
+            <a:r>
+              <a:t>Dr Linda Bacon's reframe: if you numb, you don't have a problem with food or wine or your phone, you have a problem with taking care of yourself, and with not feeling safe enough to feel. The numbing falls away as you meet your needs and build safety. Are you with me?</a:t>
+            </a:r>
+          </a:p>
+        </p:txBody>
+      </p:sp>
+      <p:sp>
+        <p:nvSpPr>
+          <p:cNvPr id="4" name="Slide Number Placeholder 3"/>
+          <p:cNvSpPr>
+            <a:spLocks noGrp="1"/>
+          </p:cNvSpPr>
+          <p:nvPr>
+            <p:ph type="sldNum" idx="5" sz="quarter"/>
+          </p:nvPr>
+        </p:nvSpPr>
+        <p:spPr/>
+      </p:sp>
+    </p:spTree>
+  </p:cSld>
+  <p:clrMapOvr>
+    <a:masterClrMapping/>
+  </p:clrMapOvr>
+</p:notes>
+</file>
+
+<file path=ppt/notesSlides/notesSlide13.xml><?xml version="1.0" encoding="utf-8"?>
+<p:notes xmlns:a="http://schemas.openxmlformats.org/drawingml/2006/main" xmlns:p="http://schemas.openxmlformats.org/presentationml/2006/main" xmlns:r="http://schemas.openxmlformats.org/officeDocument/2006/relationships">
+  <p:cSld>
+    <p:spTree>
+      <p:nvGrpSpPr>
+        <p:cNvPr id="1" name=""/>
+        <p:cNvGrpSpPr/>
+        <p:nvPr/>
+      </p:nvGrpSpPr>
+      <p:grpSpPr>
+        <a:xfrm>
+          <a:off x="0" y="0"/>
+          <a:ext cx="0" cy="0"/>
+          <a:chOff x="0" y="0"/>
+          <a:chExt cx="0" cy="0"/>
+        </a:xfrm>
+      </p:grpSpPr>
+      <p:sp>
+        <p:nvSpPr>
+          <p:cNvPr id="2" name="Slide Image Placeholder 1"/>
+          <p:cNvSpPr>
+            <a:spLocks noGrp="1"/>
+          </p:cNvSpPr>
+          <p:nvPr>
+            <p:ph type="sldImg" idx="2"/>
+          </p:nvPr>
+        </p:nvSpPr>
+        <p:spPr/>
+      </p:sp>
+      <p:sp>
+        <p:nvSpPr>
+          <p:cNvPr id="3" name="Notes Placeholder 2"/>
+          <p:cNvSpPr>
+            <a:spLocks noGrp="1"/>
+          </p:cNvSpPr>
+          <p:nvPr>
+            <p:ph type="body" idx="3" sz="quarter"/>
+          </p:nvPr>
+        </p:nvSpPr>
+        <p:spPr/>
+        <p:txBody>
+          <a:bodyPr/>
+          <a:lstStyle/>
+          <a:p>
+            <a:r>
+              <a:t>Guide the practice, hands on heart: 'How do you feel? What's going on for you?' Listen. Then 'I hear you feel...' and name it. If it's hard: 'I see this is difficult. I am here.' Nothing to change, just being with yourself. One of the fastest ways back to safety.</a:t>
+            </a:r>
+          </a:p>
+        </p:txBody>
+      </p:sp>
+      <p:sp>
+        <p:nvSpPr>
+          <p:cNvPr id="4" name="Slide Number Placeholder 3"/>
+          <p:cNvSpPr>
+            <a:spLocks noGrp="1"/>
+          </p:cNvSpPr>
+          <p:nvPr>
+            <p:ph type="sldNum" idx="5" sz="quarter"/>
+          </p:nvPr>
+        </p:nvSpPr>
+        <p:spPr/>
+      </p:sp>
+    </p:spTree>
+  </p:cSld>
+  <p:clrMapOvr>
+    <a:masterClrMapping/>
+  </p:clrMapOvr>
+</p:notes>
+</file>
+
+<file path=ppt/notesSlides/notesSlide14.xml><?xml version="1.0" encoding="utf-8"?>
+<p:notes xmlns:a="http://schemas.openxmlformats.org/drawingml/2006/main" xmlns:p="http://schemas.openxmlformats.org/presentationml/2006/main" xmlns:r="http://schemas.openxmlformats.org/officeDocument/2006/relationships">
+  <p:cSld>
+    <p:spTree>
+      <p:nvGrpSpPr>
+        <p:cNvPr id="1" name=""/>
+        <p:cNvGrpSpPr/>
+        <p:nvPr/>
+      </p:nvGrpSpPr>
+      <p:grpSpPr>
+        <a:xfrm>
+          <a:off x="0" y="0"/>
+          <a:ext cx="0" cy="0"/>
+          <a:chOff x="0" y="0"/>
+          <a:chExt cx="0" cy="0"/>
+        </a:xfrm>
+      </p:grpSpPr>
+      <p:sp>
+        <p:nvSpPr>
+          <p:cNvPr id="2" name="Slide Image Placeholder 1"/>
+          <p:cNvSpPr>
+            <a:spLocks noGrp="1"/>
+          </p:cNvSpPr>
+          <p:nvPr>
+            <p:ph type="sldImg" idx="2"/>
+          </p:nvPr>
+        </p:nvSpPr>
+        <p:spPr/>
+      </p:sp>
+      <p:sp>
+        <p:nvSpPr>
+          <p:cNvPr id="3" name="Notes Placeholder 2"/>
+          <p:cNvSpPr>
+            <a:spLocks noGrp="1"/>
+          </p:cNvSpPr>
+          <p:nvPr>
+            <p:ph type="body" idx="3" sz="quarter"/>
+          </p:nvPr>
+        </p:nvSpPr>
+        <p:spPr/>
+        <p:txBody>
+          <a:bodyPr/>
+          <a:lstStyle/>
+          <a:p>
+            <a:r>
+              <a:t>Broadcast. In pairs, Partner A hands on heart, out loud to B: 'How do you feel? What's going on for you?' Answer honestly. Partner B's only words back: 'I hear you feel...' No advice. Swap. Main-room: what happened in your body when someone just listened?</a:t>
+            </a:r>
+          </a:p>
+        </p:txBody>
+      </p:sp>
+      <p:sp>
+        <p:nvSpPr>
+          <p:cNvPr id="4" name="Slide Number Placeholder 3"/>
+          <p:cNvSpPr>
+            <a:spLocks noGrp="1"/>
+          </p:cNvSpPr>
+          <p:nvPr>
+            <p:ph type="sldNum" idx="5" sz="quarter"/>
+          </p:nvPr>
+        </p:nvSpPr>
+        <p:spPr/>
+      </p:sp>
+    </p:spTree>
+  </p:cSld>
+  <p:clrMapOvr>
+    <a:masterClrMapping/>
+  </p:clrMapOvr>
+</p:notes>
+</file>
+
+<file path=ppt/notesSlides/notesSlide15.xml><?xml version="1.0" encoding="utf-8"?>
+<p:notes xmlns:a="http://schemas.openxmlformats.org/drawingml/2006/main" xmlns:p="http://schemas.openxmlformats.org/presentationml/2006/main" xmlns:r="http://schemas.openxmlformats.org/officeDocument/2006/relationships">
+  <p:cSld>
+    <p:spTree>
+      <p:nvGrpSpPr>
+        <p:cNvPr id="1" name=""/>
+        <p:cNvGrpSpPr/>
+        <p:nvPr/>
+      </p:nvGrpSpPr>
+      <p:grpSpPr>
+        <a:xfrm>
+          <a:off x="0" y="0"/>
+          <a:ext cx="0" cy="0"/>
+          <a:chOff x="0" y="0"/>
+          <a:chExt cx="0" cy="0"/>
+        </a:xfrm>
+      </p:grpSpPr>
+      <p:sp>
+        <p:nvSpPr>
+          <p:cNvPr id="2" name="Slide Image Placeholder 1"/>
+          <p:cNvSpPr>
+            <a:spLocks noGrp="1"/>
+          </p:cNvSpPr>
+          <p:nvPr>
+            <p:ph type="sldImg" idx="2"/>
+          </p:nvPr>
+        </p:nvSpPr>
+        <p:spPr/>
+      </p:sp>
+      <p:sp>
+        <p:nvSpPr>
+          <p:cNvPr id="3" name="Notes Placeholder 2"/>
+          <p:cNvSpPr>
+            <a:spLocks noGrp="1"/>
+          </p:cNvSpPr>
+          <p:nvPr>
+            <p:ph type="body" idx="3" sz="quarter"/>
+          </p:nvPr>
+        </p:nvSpPr>
+        <p:spPr/>
+        <p:txBody>
+          <a:bodyPr/>
+          <a:lstStyle/>
+          <a:p>
+            <a:r>
+              <a:t>Take-home: when a feeling rises or you catch yourself reaching to numb, first ask 'Am I safe? Am I connected to myself?' Then hands on heart, 'How do you feel?' and listen. That's the whole practice. Session 2 is what to do when the feeling is a wave.</a:t>
+            </a:r>
+          </a:p>
+        </p:txBody>
+      </p:sp>
+      <p:sp>
+        <p:nvSpPr>
+          <p:cNvPr id="4" name="Slide Number Placeholder 3"/>
+          <p:cNvSpPr>
+            <a:spLocks noGrp="1"/>
+          </p:cNvSpPr>
+          <p:nvPr>
+            <p:ph type="sldNum" idx="5" sz="quarter"/>
+          </p:nvPr>
+        </p:nvSpPr>
+        <p:spPr/>
+      </p:sp>
+    </p:spTree>
+  </p:cSld>
+  <p:clrMapOvr>
+    <a:masterClrMapping/>
+  </p:clrMapOvr>
+</p:notes>
+</file>
+
+<file path=ppt/notesSlides/notesSlide16.xml><?xml version="1.0" encoding="utf-8"?>
+<p:notes xmlns:a="http://schemas.openxmlformats.org/drawingml/2006/main" xmlns:p="http://schemas.openxmlformats.org/presentationml/2006/main" xmlns:r="http://schemas.openxmlformats.org/officeDocument/2006/relationships">
+  <p:cSld>
+    <p:spTree>
+      <p:nvGrpSpPr>
+        <p:cNvPr id="1" name=""/>
+        <p:cNvGrpSpPr/>
+        <p:nvPr/>
+      </p:nvGrpSpPr>
+      <p:grpSpPr>
+        <a:xfrm>
+          <a:off x="0" y="0"/>
+          <a:ext cx="0" cy="0"/>
+          <a:chOff x="0" y="0"/>
+          <a:chExt cx="0" cy="0"/>
+        </a:xfrm>
+      </p:grpSpPr>
+      <p:sp>
+        <p:nvSpPr>
+          <p:cNvPr id="2" name="Slide Image Placeholder 1"/>
+          <p:cNvSpPr>
+            <a:spLocks noGrp="1"/>
+          </p:cNvSpPr>
+          <p:nvPr>
+            <p:ph type="sldImg" idx="2"/>
+          </p:nvPr>
+        </p:nvSpPr>
+        <p:spPr/>
+      </p:sp>
+      <p:sp>
+        <p:nvSpPr>
+          <p:cNvPr id="3" name="Notes Placeholder 2"/>
+          <p:cNvSpPr>
+            <a:spLocks noGrp="1"/>
+          </p:cNvSpPr>
+          <p:nvPr>
+            <p:ph type="body" idx="3" sz="quarter"/>
+          </p:nvPr>
+        </p:nvSpPr>
+        <p:spPr/>
+        <p:txBody>
+          <a:bodyPr/>
+          <a:lstStyle/>
+          <a:p>
+            <a:r>
+              <a:t>Session 2. Soften them in and anchor safety, then recap: lack of safety is the problem, not the emotions. Go-round: one feeling I've been carrying this week. Pose the reflection questions for later: what feels too big? where am I braced? what brings me back to safety?</a:t>
+            </a:r>
+          </a:p>
+        </p:txBody>
+      </p:sp>
+      <p:sp>
+        <p:nvSpPr>
+          <p:cNvPr id="4" name="Slide Number Placeholder 3"/>
+          <p:cNvSpPr>
+            <a:spLocks noGrp="1"/>
+          </p:cNvSpPr>
+          <p:nvPr>
+            <p:ph type="sldNum" idx="5" sz="quarter"/>
+          </p:nvPr>
+        </p:nvSpPr>
+        <p:spPr/>
+      </p:sp>
+    </p:spTree>
+  </p:cSld>
+  <p:clrMapOvr>
+    <a:masterClrMapping/>
+  </p:clrMapOvr>
+</p:notes>
+</file>
+
+<file path=ppt/notesSlides/notesSlide17.xml><?xml version="1.0" encoding="utf-8"?>
+<p:notes xmlns:a="http://schemas.openxmlformats.org/drawingml/2006/main" xmlns:p="http://schemas.openxmlformats.org/presentationml/2006/main" xmlns:r="http://schemas.openxmlformats.org/officeDocument/2006/relationships">
+  <p:cSld>
+    <p:spTree>
+      <p:nvGrpSpPr>
+        <p:cNvPr id="1" name=""/>
+        <p:cNvGrpSpPr/>
+        <p:nvPr/>
+      </p:nvGrpSpPr>
+      <p:grpSpPr>
+        <a:xfrm>
+          <a:off x="0" y="0"/>
+          <a:ext cx="0" cy="0"/>
+          <a:chOff x="0" y="0"/>
+          <a:chExt cx="0" cy="0"/>
+        </a:xfrm>
+      </p:grpSpPr>
+      <p:sp>
+        <p:nvSpPr>
+          <p:cNvPr id="2" name="Slide Image Placeholder 1"/>
+          <p:cNvSpPr>
+            <a:spLocks noGrp="1"/>
+          </p:cNvSpPr>
+          <p:nvPr>
+            <p:ph type="sldImg" idx="2"/>
+          </p:nvPr>
+        </p:nvSpPr>
+        <p:spPr/>
+      </p:sp>
+      <p:sp>
+        <p:nvSpPr>
+          <p:cNvPr id="3" name="Notes Placeholder 2"/>
+          <p:cNvSpPr>
+            <a:spLocks noGrp="1"/>
+          </p:cNvSpPr>
+          <p:nvPr>
+            <p:ph type="body" idx="3" sz="quarter"/>
+          </p:nvPr>
+        </p:nvSpPr>
+        <p:spPr/>
+        <p:txBody>
+          <a:bodyPr/>
+          <a:lstStyle/>
+          <a:p>
+            <a:r>
+              <a:t>Before we go near a big feeling tonight, anchor safety: feet on the floor, hand on your heart, 'Right now, in this moment, I am here, and I am safe.'</a:t>
+            </a:r>
+          </a:p>
+        </p:txBody>
+      </p:sp>
+      <p:sp>
+        <p:nvSpPr>
+          <p:cNvPr id="4" name="Slide Number Placeholder 3"/>
+          <p:cNvSpPr>
+            <a:spLocks noGrp="1"/>
+          </p:cNvSpPr>
+          <p:nvPr>
+            <p:ph type="sldNum" idx="5" sz="quarter"/>
+          </p:nvPr>
+        </p:nvSpPr>
+        <p:spPr/>
+      </p:sp>
+    </p:spTree>
+  </p:cSld>
+  <p:clrMapOvr>
+    <a:masterClrMapping/>
+  </p:clrMapOvr>
+</p:notes>
+</file>
+
+<file path=ppt/notesSlides/notesSlide18.xml><?xml version="1.0" encoding="utf-8"?>
+<p:notes xmlns:a="http://schemas.openxmlformats.org/drawingml/2006/main" xmlns:p="http://schemas.openxmlformats.org/presentationml/2006/main" xmlns:r="http://schemas.openxmlformats.org/officeDocument/2006/relationships">
+  <p:cSld>
+    <p:spTree>
+      <p:nvGrpSpPr>
+        <p:cNvPr id="1" name=""/>
+        <p:cNvGrpSpPr/>
+        <p:nvPr/>
+      </p:nvGrpSpPr>
+      <p:grpSpPr>
+        <a:xfrm>
+          <a:off x="0" y="0"/>
+          <a:ext cx="0" cy="0"/>
+          <a:chOff x="0" y="0"/>
+          <a:chExt cx="0" cy="0"/>
+        </a:xfrm>
+      </p:grpSpPr>
+      <p:sp>
+        <p:nvSpPr>
+          <p:cNvPr id="2" name="Slide Image Placeholder 1"/>
+          <p:cNvSpPr>
+            <a:spLocks noGrp="1"/>
+          </p:cNvSpPr>
+          <p:nvPr>
+            <p:ph type="sldImg" idx="2"/>
+          </p:nvPr>
+        </p:nvSpPr>
+        <p:spPr/>
+      </p:sp>
+      <p:sp>
+        <p:nvSpPr>
+          <p:cNvPr id="3" name="Notes Placeholder 2"/>
+          <p:cNvSpPr>
+            <a:spLocks noGrp="1"/>
+          </p:cNvSpPr>
+          <p:nvPr>
+            <p:ph type="body" idx="3" sz="quarter"/>
+          </p:nvPr>
+        </p:nvSpPr>
+        <p:spPr/>
+        <p:txBody>
+          <a:bodyPr/>
+          <a:lstStyle/>
+          <a:p>
+            <a:r>
+              <a:t>Pose and let them sit: What feeling, if I let it, feels too big? Where do I feel it in my body, where am I braced? What brings me back to safety?</a:t>
+            </a:r>
+          </a:p>
+        </p:txBody>
+      </p:sp>
+      <p:sp>
+        <p:nvSpPr>
+          <p:cNvPr id="4" name="Slide Number Placeholder 3"/>
+          <p:cNvSpPr>
+            <a:spLocks noGrp="1"/>
+          </p:cNvSpPr>
+          <p:nvPr>
+            <p:ph type="sldNum" idx="5" sz="quarter"/>
+          </p:nvPr>
+        </p:nvSpPr>
+        <p:spPr/>
+      </p:sp>
+    </p:spTree>
+  </p:cSld>
+  <p:clrMapOvr>
+    <a:masterClrMapping/>
+  </p:clrMapOvr>
+</p:notes>
+</file>
+
+<file path=ppt/notesSlides/notesSlide19.xml><?xml version="1.0" encoding="utf-8"?>
+<p:notes xmlns:a="http://schemas.openxmlformats.org/drawingml/2006/main" xmlns:p="http://schemas.openxmlformats.org/presentationml/2006/main" xmlns:r="http://schemas.openxmlformats.org/officeDocument/2006/relationships">
+  <p:cSld>
+    <p:spTree>
+      <p:nvGrpSpPr>
+        <p:cNvPr id="1" name=""/>
+        <p:cNvGrpSpPr/>
+        <p:nvPr/>
+      </p:nvGrpSpPr>
+      <p:grpSpPr>
+        <a:xfrm>
+          <a:off x="0" y="0"/>
+          <a:ext cx="0" cy="0"/>
+          <a:chOff x="0" y="0"/>
+          <a:chExt cx="0" cy="0"/>
+        </a:xfrm>
+      </p:grpSpPr>
+      <p:sp>
+        <p:nvSpPr>
+          <p:cNvPr id="2" name="Slide Image Placeholder 1"/>
+          <p:cNvSpPr>
+            <a:spLocks noGrp="1"/>
+          </p:cNvSpPr>
+          <p:nvPr>
+            <p:ph type="sldImg" idx="2"/>
+          </p:nvPr>
+        </p:nvSpPr>
+        <p:spPr/>
+      </p:sp>
+      <p:sp>
+        <p:nvSpPr>
+          <p:cNvPr id="3" name="Notes Placeholder 2"/>
+          <p:cNvSpPr>
+            <a:spLocks noGrp="1"/>
+          </p:cNvSpPr>
+          <p:nvPr>
+            <p:ph type="body" idx="3" sz="quarter"/>
+          </p:nvPr>
+        </p:nvSpPr>
+        <p:spPr/>
+        <p:txBody>
+          <a:bodyPr/>
+          <a:lstStyle/>
+          <a:p>
+            <a:r>
+              <a:t>Not shutting it out, not drowning. Feeling into it without being taken over. The third way, right in the middle.</a:t>
+            </a:r>
+          </a:p>
+        </p:txBody>
+      </p:sp>
+      <p:sp>
+        <p:nvSpPr>
+          <p:cNvPr id="4" name="Slide Number Placeholder 3"/>
+          <p:cNvSpPr>
+            <a:spLocks noGrp="1"/>
+          </p:cNvSpPr>
+          <p:nvPr>
+            <p:ph type="sldNum" idx="5" sz="quarter"/>
+          </p:nvPr>
+        </p:nvSpPr>
+        <p:spPr/>
+      </p:sp>
+    </p:spTree>
+  </p:cSld>
+  <p:clrMapOvr>
+    <a:masterClrMapping/>
+  </p:clrMapOvr>
+</p:notes>
+</file>
+
+<file path=ppt/notesSlides/notesSlide2.xml><?xml version="1.0" encoding="utf-8"?>
+<p:notes xmlns:a="http://schemas.openxmlformats.org/drawingml/2006/main" xmlns:p="http://schemas.openxmlformats.org/presentationml/2006/main" xmlns:r="http://schemas.openxmlformats.org/officeDocument/2006/relationships">
+  <p:cSld>
+    <p:spTree>
+      <p:nvGrpSpPr>
+        <p:cNvPr id="1" name=""/>
+        <p:cNvGrpSpPr/>
+        <p:nvPr/>
+      </p:nvGrpSpPr>
+      <p:grpSpPr>
+        <a:xfrm>
+          <a:off x="0" y="0"/>
+          <a:ext cx="0" cy="0"/>
+          <a:chOff x="0" y="0"/>
+          <a:chExt cx="0" cy="0"/>
+        </a:xfrm>
+      </p:grpSpPr>
+      <p:sp>
+        <p:nvSpPr>
+          <p:cNvPr id="2" name="Slide Image Placeholder 1"/>
+          <p:cNvSpPr>
+            <a:spLocks noGrp="1"/>
+          </p:cNvSpPr>
+          <p:nvPr>
+            <p:ph type="sldImg" idx="2"/>
+          </p:nvPr>
+        </p:nvSpPr>
+        <p:spPr/>
+      </p:sp>
+      <p:sp>
+        <p:nvSpPr>
+          <p:cNvPr id="3" name="Notes Placeholder 2"/>
+          <p:cNvSpPr>
+            <a:spLocks noGrp="1"/>
+          </p:cNvSpPr>
+          <p:nvPr>
+            <p:ph type="body" idx="3" sz="quarter"/>
+          </p:nvPr>
+        </p:nvSpPr>
+        <p:spPr/>
+        <p:txBody>
+          <a:bodyPr/>
+          <a:lstStyle/>
+          <a:p>
+            <a:r>
+              <a:t>The whole frame for both sessions: lack of safety is the problem, not the emotions. Emotions aren't dangerous, being flooded is. We get flooded when we try to feel big things with no safety underneath.</a:t>
+            </a:r>
+          </a:p>
+        </p:txBody>
+      </p:sp>
+      <p:sp>
+        <p:nvSpPr>
+          <p:cNvPr id="4" name="Slide Number Placeholder 3"/>
+          <p:cNvSpPr>
+            <a:spLocks noGrp="1"/>
+          </p:cNvSpPr>
+          <p:nvPr>
+            <p:ph type="sldNum" idx="5" sz="quarter"/>
+          </p:nvPr>
+        </p:nvSpPr>
+        <p:spPr/>
+      </p:sp>
+    </p:spTree>
+  </p:cSld>
+  <p:clrMapOvr>
+    <a:masterClrMapping/>
+  </p:clrMapOvr>
+</p:notes>
+</file>
+
+<file path=ppt/notesSlides/notesSlide20.xml><?xml version="1.0" encoding="utf-8"?>
+<p:notes xmlns:a="http://schemas.openxmlformats.org/drawingml/2006/main" xmlns:p="http://schemas.openxmlformats.org/presentationml/2006/main" xmlns:r="http://schemas.openxmlformats.org/officeDocument/2006/relationships">
+  <p:cSld>
+    <p:spTree>
+      <p:nvGrpSpPr>
+        <p:cNvPr id="1" name=""/>
+        <p:cNvGrpSpPr/>
+        <p:nvPr/>
+      </p:nvGrpSpPr>
+      <p:grpSpPr>
+        <a:xfrm>
+          <a:off x="0" y="0"/>
+          <a:ext cx="0" cy="0"/>
+          <a:chOff x="0" y="0"/>
+          <a:chExt cx="0" cy="0"/>
+        </a:xfrm>
+      </p:grpSpPr>
+      <p:sp>
+        <p:nvSpPr>
+          <p:cNvPr id="2" name="Slide Image Placeholder 1"/>
+          <p:cNvSpPr>
+            <a:spLocks noGrp="1"/>
+          </p:cNvSpPr>
+          <p:nvPr>
+            <p:ph type="sldImg" idx="2"/>
+          </p:nvPr>
+        </p:nvSpPr>
+        <p:spPr/>
+      </p:sp>
+      <p:sp>
+        <p:nvSpPr>
+          <p:cNvPr id="3" name="Notes Placeholder 2"/>
+          <p:cNvSpPr>
+            <a:spLocks noGrp="1"/>
+          </p:cNvSpPr>
+          <p:nvPr>
+            <p:ph type="body" idx="3" sz="quarter"/>
+          </p:nvPr>
+        </p:nvSpPr>
+        <p:spPr/>
+        <p:txBody>
+          <a:bodyPr/>
+          <a:lstStyle/>
+          <a:p>
+            <a:r>
+              <a:t>Grief comes in waves. You don't feel all of it at once; it rises, crests, passes for now, then returns. That's grief doing what grief does, not you failing.</a:t>
+            </a:r>
+          </a:p>
+        </p:txBody>
+      </p:sp>
+      <p:sp>
+        <p:nvSpPr>
+          <p:cNvPr id="4" name="Slide Number Placeholder 3"/>
+          <p:cNvSpPr>
+            <a:spLocks noGrp="1"/>
+          </p:cNvSpPr>
+          <p:nvPr>
+            <p:ph type="sldNum" idx="5" sz="quarter"/>
+          </p:nvPr>
+        </p:nvSpPr>
+        <p:spPr/>
+      </p:sp>
+    </p:spTree>
+  </p:cSld>
+  <p:clrMapOvr>
+    <a:masterClrMapping/>
+  </p:clrMapOvr>
+</p:notes>
+</file>
+
+<file path=ppt/notesSlides/notesSlide21.xml><?xml version="1.0" encoding="utf-8"?>
+<p:notes xmlns:a="http://schemas.openxmlformats.org/drawingml/2006/main" xmlns:p="http://schemas.openxmlformats.org/presentationml/2006/main" xmlns:r="http://schemas.openxmlformats.org/officeDocument/2006/relationships">
+  <p:cSld>
+    <p:spTree>
+      <p:nvGrpSpPr>
+        <p:cNvPr id="1" name=""/>
+        <p:cNvGrpSpPr/>
+        <p:nvPr/>
+      </p:nvGrpSpPr>
+      <p:grpSpPr>
+        <a:xfrm>
+          <a:off x="0" y="0"/>
+          <a:ext cx="0" cy="0"/>
+          <a:chOff x="0" y="0"/>
+          <a:chExt cx="0" cy="0"/>
+        </a:xfrm>
+      </p:grpSpPr>
+      <p:sp>
+        <p:nvSpPr>
+          <p:cNvPr id="2" name="Slide Image Placeholder 1"/>
+          <p:cNvSpPr>
+            <a:spLocks noGrp="1"/>
+          </p:cNvSpPr>
+          <p:nvPr>
+            <p:ph type="sldImg" idx="2"/>
+          </p:nvPr>
+        </p:nvSpPr>
+        <p:spPr/>
+      </p:sp>
+      <p:sp>
+        <p:nvSpPr>
+          <p:cNvPr id="3" name="Notes Placeholder 2"/>
+          <p:cNvSpPr>
+            <a:spLocks noGrp="1"/>
+          </p:cNvSpPr>
+          <p:nvPr>
+            <p:ph type="body" idx="3" sz="quarter"/>
+          </p:nvPr>
+        </p:nvSpPr>
+        <p:spPr/>
+        <p:txBody>
+          <a:bodyPr/>
+          <a:lstStyle/>
+          <a:p>
+            <a:r>
+              <a:t>The skill of self-regulation, titrating: go into the feeling for a breath or two, really feel it, then deliberately come back to safety, feet, breath, hand on heart. A little in, a little out. The opposite of numbing, and of drowning.</a:t>
+            </a:r>
+          </a:p>
+        </p:txBody>
+      </p:sp>
+      <p:sp>
+        <p:nvSpPr>
+          <p:cNvPr id="4" name="Slide Number Placeholder 3"/>
+          <p:cNvSpPr>
+            <a:spLocks noGrp="1"/>
+          </p:cNvSpPr>
+          <p:nvPr>
+            <p:ph type="sldNum" idx="5" sz="quarter"/>
+          </p:nvPr>
+        </p:nvSpPr>
+        <p:spPr/>
+      </p:sp>
+    </p:spTree>
+  </p:cSld>
+  <p:clrMapOvr>
+    <a:masterClrMapping/>
+  </p:clrMapOvr>
+</p:notes>
+</file>
+
+<file path=ppt/notesSlides/notesSlide22.xml><?xml version="1.0" encoding="utf-8"?>
+<p:notes xmlns:a="http://schemas.openxmlformats.org/drawingml/2006/main" xmlns:p="http://schemas.openxmlformats.org/presentationml/2006/main" xmlns:r="http://schemas.openxmlformats.org/officeDocument/2006/relationships">
+  <p:cSld>
+    <p:spTree>
+      <p:nvGrpSpPr>
+        <p:cNvPr id="1" name=""/>
+        <p:cNvGrpSpPr/>
+        <p:nvPr/>
+      </p:nvGrpSpPr>
+      <p:grpSpPr>
+        <a:xfrm>
+          <a:off x="0" y="0"/>
+          <a:ext cx="0" cy="0"/>
+          <a:chOff x="0" y="0"/>
+          <a:chExt cx="0" cy="0"/>
+        </a:xfrm>
+      </p:grpSpPr>
+      <p:sp>
+        <p:nvSpPr>
+          <p:cNvPr id="2" name="Slide Image Placeholder 1"/>
+          <p:cNvSpPr>
+            <a:spLocks noGrp="1"/>
+          </p:cNvSpPr>
+          <p:nvPr>
+            <p:ph type="sldImg" idx="2"/>
+          </p:nvPr>
+        </p:nvSpPr>
+        <p:spPr/>
+      </p:sp>
+      <p:sp>
+        <p:nvSpPr>
+          <p:cNvPr id="3" name="Notes Placeholder 2"/>
+          <p:cNvSpPr>
+            <a:spLocks noGrp="1"/>
+          </p:cNvSpPr>
+          <p:nvPr>
+            <p:ph type="body" idx="3" sz="quarter"/>
+          </p:nvPr>
+        </p:nvSpPr>
+        <p:spPr/>
+        <p:txBody>
+          <a:bodyPr/>
+          <a:lstStyle/>
+          <a:p>
+            <a:r>
+              <a:t>While the wave moves, keep part of your attention here: name five things you see, 'right now I am here and I am safe.' That's how you feel it without disappearing into it.</a:t>
+            </a:r>
+          </a:p>
+        </p:txBody>
+      </p:sp>
+      <p:sp>
+        <p:nvSpPr>
+          <p:cNvPr id="4" name="Slide Number Placeholder 3"/>
+          <p:cNvSpPr>
+            <a:spLocks noGrp="1"/>
+          </p:cNvSpPr>
+          <p:nvPr>
+            <p:ph type="sldNum" idx="5" sz="quarter"/>
+          </p:nvPr>
+        </p:nvSpPr>
+        <p:spPr/>
+      </p:sp>
+    </p:spTree>
+  </p:cSld>
+  <p:clrMapOvr>
+    <a:masterClrMapping/>
+  </p:clrMapOvr>
+</p:notes>
+</file>
+
+<file path=ppt/notesSlides/notesSlide23.xml><?xml version="1.0" encoding="utf-8"?>
+<p:notes xmlns:a="http://schemas.openxmlformats.org/drawingml/2006/main" xmlns:p="http://schemas.openxmlformats.org/presentationml/2006/main" xmlns:r="http://schemas.openxmlformats.org/officeDocument/2006/relationships">
+  <p:cSld>
+    <p:spTree>
+      <p:nvGrpSpPr>
+        <p:cNvPr id="1" name=""/>
+        <p:cNvGrpSpPr/>
+        <p:nvPr/>
+      </p:nvGrpSpPr>
+      <p:grpSpPr>
+        <a:xfrm>
+          <a:off x="0" y="0"/>
+          <a:ext cx="0" cy="0"/>
+          <a:chOff x="0" y="0"/>
+          <a:chExt cx="0" cy="0"/>
+        </a:xfrm>
+      </p:grpSpPr>
+      <p:sp>
+        <p:nvSpPr>
+          <p:cNvPr id="2" name="Slide Image Placeholder 1"/>
+          <p:cNvSpPr>
+            <a:spLocks noGrp="1"/>
+          </p:cNvSpPr>
+          <p:nvPr>
+            <p:ph type="sldImg" idx="2"/>
+          </p:nvPr>
+        </p:nvSpPr>
+        <p:spPr/>
+      </p:sp>
+      <p:sp>
+        <p:nvSpPr>
+          <p:cNvPr id="3" name="Notes Placeholder 2"/>
+          <p:cNvSpPr>
+            <a:spLocks noGrp="1"/>
+          </p:cNvSpPr>
+          <p:nvPr>
+            <p:ph type="body" idx="3" sz="quarter"/>
+          </p:nvPr>
+        </p:nvSpPr>
+        <p:spPr/>
+        <p:txBody>
+          <a:bodyPr/>
+          <a:lstStyle/>
+          <a:p>
+            <a:r>
+              <a:t>Safety first: tell them to pick something that's a 3 or 4 out of 10, not their biggest thing. Broadcast. In pairs, A brings a manageable feeling, feels it one or two breaths, says where it is; B guides A back to safety; a little in, a little out, three times; swap. B just holds the safety anchor. Main-room: what did you notice about coming back on purpose?</a:t>
+            </a:r>
+          </a:p>
+        </p:txBody>
+      </p:sp>
+      <p:sp>
+        <p:nvSpPr>
+          <p:cNvPr id="4" name="Slide Number Placeholder 3"/>
+          <p:cNvSpPr>
+            <a:spLocks noGrp="1"/>
+          </p:cNvSpPr>
+          <p:nvPr>
+            <p:ph type="sldNum" idx="5" sz="quarter"/>
+          </p:nvPr>
+        </p:nvSpPr>
+        <p:spPr/>
+      </p:sp>
+    </p:spTree>
+  </p:cSld>
+  <p:clrMapOvr>
+    <a:masterClrMapping/>
+  </p:clrMapOvr>
+</p:notes>
+</file>
+
+<file path=ppt/notesSlides/notesSlide24.xml><?xml version="1.0" encoding="utf-8"?>
+<p:notes xmlns:a="http://schemas.openxmlformats.org/drawingml/2006/main" xmlns:p="http://schemas.openxmlformats.org/presentationml/2006/main" xmlns:r="http://schemas.openxmlformats.org/officeDocument/2006/relationships">
+  <p:cSld>
+    <p:spTree>
+      <p:nvGrpSpPr>
+        <p:cNvPr id="1" name=""/>
+        <p:cNvGrpSpPr/>
+        <p:nvPr/>
+      </p:nvGrpSpPr>
+      <p:grpSpPr>
+        <a:xfrm>
+          <a:off x="0" y="0"/>
+          <a:ext cx="0" cy="0"/>
+          <a:chOff x="0" y="0"/>
+          <a:chExt cx="0" cy="0"/>
+        </a:xfrm>
+      </p:grpSpPr>
+      <p:sp>
+        <p:nvSpPr>
+          <p:cNvPr id="2" name="Slide Image Placeholder 1"/>
+          <p:cNvSpPr>
+            <a:spLocks noGrp="1"/>
+          </p:cNvSpPr>
+          <p:nvPr>
+            <p:ph type="sldImg" idx="2"/>
+          </p:nvPr>
+        </p:nvSpPr>
+        <p:spPr/>
+      </p:sp>
+      <p:sp>
+        <p:nvSpPr>
+          <p:cNvPr id="3" name="Notes Placeholder 2"/>
+          <p:cNvSpPr>
+            <a:spLocks noGrp="1"/>
+          </p:cNvSpPr>
+          <p:nvPr>
+            <p:ph type="body" idx="3" sz="quarter"/>
+          </p:nvPr>
+        </p:nvSpPr>
+        <p:spPr/>
+        <p:txBody>
+          <a:bodyPr/>
+          <a:lstStyle/>
+          <a:p>
+            <a:r>
+              <a:t>You can make peace in your head, and your body can still be holding it. The body lets go through breath, tears, moving, being held. Lead one minute: hand on the braced place, three long breaths, an audible sigh on each out-breath. Then soothe: hands on heart, 'I see this is hard. I am here.'</a:t>
+            </a:r>
+          </a:p>
+        </p:txBody>
+      </p:sp>
+      <p:sp>
+        <p:nvSpPr>
+          <p:cNvPr id="4" name="Slide Number Placeholder 3"/>
+          <p:cNvSpPr>
+            <a:spLocks noGrp="1"/>
+          </p:cNvSpPr>
+          <p:nvPr>
+            <p:ph type="sldNum" idx="5" sz="quarter"/>
+          </p:nvPr>
+        </p:nvSpPr>
+        <p:spPr/>
+      </p:sp>
+    </p:spTree>
+  </p:cSld>
+  <p:clrMapOvr>
+    <a:masterClrMapping/>
+  </p:clrMapOvr>
+</p:notes>
+</file>
+
+<file path=ppt/notesSlides/notesSlide25.xml><?xml version="1.0" encoding="utf-8"?>
+<p:notes xmlns:a="http://schemas.openxmlformats.org/drawingml/2006/main" xmlns:p="http://schemas.openxmlformats.org/presentationml/2006/main" xmlns:r="http://schemas.openxmlformats.org/officeDocument/2006/relationships">
+  <p:cSld>
+    <p:spTree>
+      <p:nvGrpSpPr>
+        <p:cNvPr id="1" name=""/>
+        <p:cNvGrpSpPr/>
+        <p:nvPr/>
+      </p:nvGrpSpPr>
+      <p:grpSpPr>
+        <a:xfrm>
+          <a:off x="0" y="0"/>
+          <a:ext cx="0" cy="0"/>
+          <a:chOff x="0" y="0"/>
+          <a:chExt cx="0" cy="0"/>
+        </a:xfrm>
+      </p:grpSpPr>
+      <p:sp>
+        <p:nvSpPr>
+          <p:cNvPr id="2" name="Slide Image Placeholder 1"/>
+          <p:cNvSpPr>
+            <a:spLocks noGrp="1"/>
+          </p:cNvSpPr>
+          <p:nvPr>
+            <p:ph type="sldImg" idx="2"/>
+          </p:nvPr>
+        </p:nvSpPr>
+        <p:spPr/>
+      </p:sp>
+      <p:sp>
+        <p:nvSpPr>
+          <p:cNvPr id="3" name="Notes Placeholder 2"/>
+          <p:cNvSpPr>
+            <a:spLocks noGrp="1"/>
+          </p:cNvSpPr>
+          <p:nvPr>
+            <p:ph type="body" idx="3" sz="quarter"/>
+          </p:nvPr>
+        </p:nvSpPr>
+        <p:spPr/>
+        <p:txBody>
+          <a:bodyPr/>
+          <a:lstStyle/>
+          <a:p>
+            <a:r>
+              <a:t>Introduce EFT, tapping, an easy and direct way to settle a big feeling and come back to safety in the body. Note you're a certified EFT practitioner and this is a quick version they can use right away.</a:t>
+            </a:r>
+          </a:p>
+        </p:txBody>
+      </p:sp>
+      <p:sp>
+        <p:nvSpPr>
+          <p:cNvPr id="4" name="Slide Number Placeholder 3"/>
+          <p:cNvSpPr>
+            <a:spLocks noGrp="1"/>
+          </p:cNvSpPr>
+          <p:nvPr>
+            <p:ph type="sldNum" idx="5" sz="quarter"/>
+          </p:nvPr>
+        </p:nvSpPr>
+        <p:spPr/>
+      </p:sp>
+    </p:spTree>
+  </p:cSld>
+  <p:clrMapOvr>
+    <a:masterClrMapping/>
+  </p:clrMapOvr>
+</p:notes>
+</file>
+
+<file path=ppt/notesSlides/notesSlide26.xml><?xml version="1.0" encoding="utf-8"?>
+<p:notes xmlns:a="http://schemas.openxmlformats.org/drawingml/2006/main" xmlns:p="http://schemas.openxmlformats.org/presentationml/2006/main" xmlns:r="http://schemas.openxmlformats.org/officeDocument/2006/relationships">
+  <p:cSld>
+    <p:spTree>
+      <p:nvGrpSpPr>
+        <p:cNvPr id="1" name=""/>
+        <p:cNvGrpSpPr/>
+        <p:nvPr/>
+      </p:nvGrpSpPr>
+      <p:grpSpPr>
+        <a:xfrm>
+          <a:off x="0" y="0"/>
+          <a:ext cx="0" cy="0"/>
+          <a:chOff x="0" y="0"/>
+          <a:chExt cx="0" cy="0"/>
+        </a:xfrm>
+      </p:grpSpPr>
+      <p:sp>
+        <p:nvSpPr>
+          <p:cNvPr id="2" name="Slide Image Placeholder 1"/>
+          <p:cNvSpPr>
+            <a:spLocks noGrp="1"/>
+          </p:cNvSpPr>
+          <p:nvPr>
+            <p:ph type="sldImg" idx="2"/>
+          </p:nvPr>
+        </p:nvSpPr>
+        <p:spPr/>
+      </p:sp>
+      <p:sp>
+        <p:nvSpPr>
+          <p:cNvPr id="3" name="Notes Placeholder 2"/>
+          <p:cNvSpPr>
+            <a:spLocks noGrp="1"/>
+          </p:cNvSpPr>
+          <p:nvPr>
+            <p:ph type="body" idx="3" sz="quarter"/>
+          </p:nvPr>
+        </p:nvSpPr>
+        <p:spPr/>
+        <p:txBody>
+          <a:bodyPr/>
+          <a:lstStyle/>
+          <a:p>
+            <a:r>
+              <a:t>Simply: tapping calms the amygdala's fight-or-flight alarm, shown on brain scans, so you shift into your logical brain and choose your response instead of being run by the feeling. It also helps the brain update: that's not a threat now, I'm safe.</a:t>
+            </a:r>
+          </a:p>
+        </p:txBody>
+      </p:sp>
+      <p:sp>
+        <p:nvSpPr>
+          <p:cNvPr id="4" name="Slide Number Placeholder 3"/>
+          <p:cNvSpPr>
+            <a:spLocks noGrp="1"/>
+          </p:cNvSpPr>
+          <p:nvPr>
+            <p:ph type="sldNum" idx="5" sz="quarter"/>
+          </p:nvPr>
+        </p:nvSpPr>
+        <p:spPr/>
+      </p:sp>
+    </p:spTree>
+  </p:cSld>
+  <p:clrMapOvr>
+    <a:masterClrMapping/>
+  </p:clrMapOvr>
+</p:notes>
+</file>
+
+<file path=ppt/notesSlides/notesSlide27.xml><?xml version="1.0" encoding="utf-8"?>
+<p:notes xmlns:a="http://schemas.openxmlformats.org/drawingml/2006/main" xmlns:p="http://schemas.openxmlformats.org/presentationml/2006/main" xmlns:r="http://schemas.openxmlformats.org/officeDocument/2006/relationships">
+  <p:cSld>
+    <p:spTree>
+      <p:nvGrpSpPr>
+        <p:cNvPr id="1" name=""/>
+        <p:cNvGrpSpPr/>
+        <p:nvPr/>
+      </p:nvGrpSpPr>
+      <p:grpSpPr>
+        <a:xfrm>
+          <a:off x="0" y="0"/>
+          <a:ext cx="0" cy="0"/>
+          <a:chOff x="0" y="0"/>
+          <a:chExt cx="0" cy="0"/>
+        </a:xfrm>
+      </p:grpSpPr>
+      <p:sp>
+        <p:nvSpPr>
+          <p:cNvPr id="2" name="Slide Image Placeholder 1"/>
+          <p:cNvSpPr>
+            <a:spLocks noGrp="1"/>
+          </p:cNvSpPr>
+          <p:nvPr>
+            <p:ph type="sldImg" idx="2"/>
+          </p:nvPr>
+        </p:nvSpPr>
+        <p:spPr/>
+      </p:sp>
+      <p:sp>
+        <p:nvSpPr>
+          <p:cNvPr id="3" name="Notes Placeholder 2"/>
+          <p:cNvSpPr>
+            <a:spLocks noGrp="1"/>
+          </p:cNvSpPr>
+          <p:nvPr>
+            <p:ph type="body" idx="3" sz="quarter"/>
+          </p:nvPr>
+        </p:nvSpPr>
+        <p:spPr/>
+        <p:txBody>
+          <a:bodyPr/>
+          <a:lstStyle/>
+          <a:p>
+            <a:r>
+              <a:t>Reassure about tapping on the 'negative': we don't attract more by naming it. We take the dirty laundry out and wash it instead of hiding it. Name it, clear it, and reframes come naturally.</a:t>
+            </a:r>
+          </a:p>
+        </p:txBody>
+      </p:sp>
+      <p:sp>
+        <p:nvSpPr>
+          <p:cNvPr id="4" name="Slide Number Placeholder 3"/>
+          <p:cNvSpPr>
+            <a:spLocks noGrp="1"/>
+          </p:cNvSpPr>
+          <p:nvPr>
+            <p:ph type="sldNum" idx="5" sz="quarter"/>
+          </p:nvPr>
+        </p:nvSpPr>
+        <p:spPr/>
+      </p:sp>
+    </p:spTree>
+  </p:cSld>
+  <p:clrMapOvr>
+    <a:masterClrMapping/>
+  </p:clrMapOvr>
+</p:notes>
+</file>
+
+<file path=ppt/notesSlides/notesSlide28.xml><?xml version="1.0" encoding="utf-8"?>
+<p:notes xmlns:a="http://schemas.openxmlformats.org/drawingml/2006/main" xmlns:p="http://schemas.openxmlformats.org/presentationml/2006/main" xmlns:r="http://schemas.openxmlformats.org/officeDocument/2006/relationships">
+  <p:cSld>
+    <p:spTree>
+      <p:nvGrpSpPr>
+        <p:cNvPr id="1" name=""/>
+        <p:cNvGrpSpPr/>
+        <p:nvPr/>
+      </p:nvGrpSpPr>
+      <p:grpSpPr>
+        <a:xfrm>
+          <a:off x="0" y="0"/>
+          <a:ext cx="0" cy="0"/>
+          <a:chOff x="0" y="0"/>
+          <a:chExt cx="0" cy="0"/>
+        </a:xfrm>
+      </p:grpSpPr>
+      <p:sp>
+        <p:nvSpPr>
+          <p:cNvPr id="2" name="Slide Image Placeholder 1"/>
+          <p:cNvSpPr>
+            <a:spLocks noGrp="1"/>
+          </p:cNvSpPr>
+          <p:nvPr>
+            <p:ph type="sldImg" idx="2"/>
+          </p:nvPr>
+        </p:nvSpPr>
+        <p:spPr/>
+      </p:sp>
+      <p:sp>
+        <p:nvSpPr>
+          <p:cNvPr id="3" name="Notes Placeholder 2"/>
+          <p:cNvSpPr>
+            <a:spLocks noGrp="1"/>
+          </p:cNvSpPr>
+          <p:nvPr>
+            <p:ph type="body" idx="3" sz="quarter"/>
+          </p:nvPr>
+        </p:nvSpPr>
+        <p:spPr/>
+        <p:txBody>
+          <a:bodyPr/>
+          <a:lstStyle/>
+          <a:p>
+            <a:r>
+              <a:t>Walk the steps: 1) choose a specific issue, rate it 1 to 10; 2) setup on the karate chop point, 'Even though I feel this, I love and accept myself,' three times; 3) tap the points saying your reminder phrase out loud; 4) breathe, re-rate, repeat until it drops. Sip water throughout.</a:t>
+            </a:r>
+          </a:p>
+        </p:txBody>
+      </p:sp>
+      <p:sp>
+        <p:nvSpPr>
+          <p:cNvPr id="4" name="Slide Number Placeholder 3"/>
+          <p:cNvSpPr>
+            <a:spLocks noGrp="1"/>
+          </p:cNvSpPr>
+          <p:nvPr>
+            <p:ph type="sldNum" idx="5" sz="quarter"/>
+          </p:nvPr>
+        </p:nvSpPr>
+        <p:spPr/>
+      </p:sp>
+    </p:spTree>
+  </p:cSld>
+  <p:clrMapOvr>
+    <a:masterClrMapping/>
+  </p:clrMapOvr>
+</p:notes>
+</file>
+
+<file path=ppt/notesSlides/notesSlide29.xml><?xml version="1.0" encoding="utf-8"?>
+<p:notes xmlns:a="http://schemas.openxmlformats.org/drawingml/2006/main" xmlns:p="http://schemas.openxmlformats.org/presentationml/2006/main" xmlns:r="http://schemas.openxmlformats.org/officeDocument/2006/relationships">
+  <p:cSld>
+    <p:spTree>
+      <p:nvGrpSpPr>
+        <p:cNvPr id="1" name=""/>
+        <p:cNvGrpSpPr/>
+        <p:nvPr/>
+      </p:nvGrpSpPr>
+      <p:grpSpPr>
+        <a:xfrm>
+          <a:off x="0" y="0"/>
+          <a:ext cx="0" cy="0"/>
+          <a:chOff x="0" y="0"/>
+          <a:chExt cx="0" cy="0"/>
+        </a:xfrm>
+      </p:grpSpPr>
+      <p:sp>
+        <p:nvSpPr>
+          <p:cNvPr id="2" name="Slide Image Placeholder 1"/>
+          <p:cNvSpPr>
+            <a:spLocks noGrp="1"/>
+          </p:cNvSpPr>
+          <p:nvPr>
+            <p:ph type="sldImg" idx="2"/>
+          </p:nvPr>
+        </p:nvSpPr>
+        <p:spPr/>
+      </p:sp>
+      <p:sp>
+        <p:nvSpPr>
+          <p:cNvPr id="3" name="Notes Placeholder 2"/>
+          <p:cNvSpPr>
+            <a:spLocks noGrp="1"/>
+          </p:cNvSpPr>
+          <p:nvPr>
+            <p:ph type="body" idx="3" sz="quarter"/>
+          </p:nvPr>
+        </p:nvSpPr>
+        <p:spPr/>
+        <p:txBody>
+          <a:bodyPr/>
+          <a:lstStyle/>
+          <a:p>
+            <a:r>
+              <a:t>Show the points on camera: top of head, eyebrow, side of the eye, under the eye, under the nose, chin, collarbone, under the arm at nipple level, wrist. If another issue surfaces mid-round, that's good, that's how we go deeper.</a:t>
+            </a:r>
+          </a:p>
+        </p:txBody>
+      </p:sp>
+      <p:sp>
+        <p:nvSpPr>
+          <p:cNvPr id="4" name="Slide Number Placeholder 3"/>
+          <p:cNvSpPr>
+            <a:spLocks noGrp="1"/>
+          </p:cNvSpPr>
+          <p:nvPr>
+            <p:ph type="sldNum" idx="5" sz="quarter"/>
+          </p:nvPr>
+        </p:nvSpPr>
+        <p:spPr/>
+      </p:sp>
+    </p:spTree>
+  </p:cSld>
+  <p:clrMapOvr>
+    <a:masterClrMapping/>
+  </p:clrMapOvr>
+</p:notes>
+</file>
+
+<file path=ppt/notesSlides/notesSlide3.xml><?xml version="1.0" encoding="utf-8"?>
+<p:notes xmlns:a="http://schemas.openxmlformats.org/drawingml/2006/main" xmlns:p="http://schemas.openxmlformats.org/presentationml/2006/main" xmlns:r="http://schemas.openxmlformats.org/officeDocument/2006/relationships">
+  <p:cSld>
+    <p:spTree>
+      <p:nvGrpSpPr>
+        <p:cNvPr id="1" name=""/>
+        <p:cNvGrpSpPr/>
+        <p:nvPr/>
+      </p:nvGrpSpPr>
+      <p:grpSpPr>
+        <a:xfrm>
+          <a:off x="0" y="0"/>
+          <a:ext cx="0" cy="0"/>
+          <a:chOff x="0" y="0"/>
+          <a:chExt cx="0" cy="0"/>
+        </a:xfrm>
+      </p:grpSpPr>
+      <p:sp>
+        <p:nvSpPr>
+          <p:cNvPr id="2" name="Slide Image Placeholder 1"/>
+          <p:cNvSpPr>
+            <a:spLocks noGrp="1"/>
+          </p:cNvSpPr>
+          <p:nvPr>
+            <p:ph type="sldImg" idx="2"/>
+          </p:nvPr>
+        </p:nvSpPr>
+        <p:spPr/>
+      </p:sp>
+      <p:sp>
+        <p:nvSpPr>
+          <p:cNvPr id="3" name="Notes Placeholder 2"/>
+          <p:cNvSpPr>
+            <a:spLocks noGrp="1"/>
+          </p:cNvSpPr>
+          <p:nvPr>
+            <p:ph type="body" idx="3" sz="quarter"/>
+          </p:nvPr>
+        </p:nvSpPr>
+        <p:spPr/>
+        <p:txBody>
+          <a:bodyPr/>
+          <a:lstStyle/>
+          <a:p>
+            <a:r>
+              <a:t>So we start with safety. We only expand, feel more, open more, when we're not overwhelmed and not sliding into our old patterns. The moment overwhelm shows up, or you reach for the numbing thing, that's not failure, it's information: come back to safety first.</a:t>
+            </a:r>
+          </a:p>
+        </p:txBody>
+      </p:sp>
+      <p:sp>
+        <p:nvSpPr>
+          <p:cNvPr id="4" name="Slide Number Placeholder 3"/>
+          <p:cNvSpPr>
+            <a:spLocks noGrp="1"/>
+          </p:cNvSpPr>
+          <p:nvPr>
+            <p:ph type="sldNum" idx="5" sz="quarter"/>
+          </p:nvPr>
+        </p:nvSpPr>
+        <p:spPr/>
+      </p:sp>
+    </p:spTree>
+  </p:cSld>
+  <p:clrMapOvr>
+    <a:masterClrMapping/>
+  </p:clrMapOvr>
+</p:notes>
+</file>
+
+<file path=ppt/notesSlides/notesSlide30.xml><?xml version="1.0" encoding="utf-8"?>
+<p:notes xmlns:a="http://schemas.openxmlformats.org/drawingml/2006/main" xmlns:p="http://schemas.openxmlformats.org/presentationml/2006/main" xmlns:r="http://schemas.openxmlformats.org/officeDocument/2006/relationships">
+  <p:cSld>
+    <p:spTree>
+      <p:nvGrpSpPr>
+        <p:cNvPr id="1" name=""/>
+        <p:cNvGrpSpPr/>
+        <p:nvPr/>
+      </p:nvGrpSpPr>
+      <p:grpSpPr>
+        <a:xfrm>
+          <a:off x="0" y="0"/>
+          <a:ext cx="0" cy="0"/>
+          <a:chOff x="0" y="0"/>
+          <a:chExt cx="0" cy="0"/>
+        </a:xfrm>
+      </p:grpSpPr>
+      <p:sp>
+        <p:nvSpPr>
+          <p:cNvPr id="2" name="Slide Image Placeholder 1"/>
+          <p:cNvSpPr>
+            <a:spLocks noGrp="1"/>
+          </p:cNvSpPr>
+          <p:nvPr>
+            <p:ph type="sldImg" idx="2"/>
+          </p:nvPr>
+        </p:nvSpPr>
+        <p:spPr/>
+      </p:sp>
+      <p:sp>
+        <p:nvSpPr>
+          <p:cNvPr id="3" name="Notes Placeholder 2"/>
+          <p:cNvSpPr>
+            <a:spLocks noGrp="1"/>
+          </p:cNvSpPr>
+          <p:nvPr>
+            <p:ph type="body" idx="3" sz="quarter"/>
+          </p:nvPr>
+        </p:nvSpPr>
+        <p:spPr/>
+        <p:txBody>
+          <a:bodyPr/>
+          <a:lstStyle/>
+          <a:p>
+            <a:r>
+              <a:t>Broadcast, or lead together first. In pairs, each picks an issue, rates 1 to 10, says it; tap through the points together saying your own reminder phrase out loud; partner keeps time and company; breathe, re-rate; second round if still high; swap. If something big surfaces, invite them back to safety and offer one-to-one support, this is everyday self-help, not trauma treatment.</a:t>
+            </a:r>
+          </a:p>
+        </p:txBody>
+      </p:sp>
+      <p:sp>
+        <p:nvSpPr>
+          <p:cNvPr id="4" name="Slide Number Placeholder 3"/>
+          <p:cNvSpPr>
+            <a:spLocks noGrp="1"/>
+          </p:cNvSpPr>
+          <p:nvPr>
+            <p:ph type="sldNum" idx="5" sz="quarter"/>
+          </p:nvPr>
+        </p:nvSpPr>
+        <p:spPr/>
+      </p:sp>
+    </p:spTree>
+  </p:cSld>
+  <p:clrMapOvr>
+    <a:masterClrMapping/>
+  </p:clrMapOvr>
+</p:notes>
+</file>
+
+<file path=ppt/notesSlides/notesSlide31.xml><?xml version="1.0" encoding="utf-8"?>
+<p:notes xmlns:a="http://schemas.openxmlformats.org/drawingml/2006/main" xmlns:p="http://schemas.openxmlformats.org/presentationml/2006/main" xmlns:r="http://schemas.openxmlformats.org/officeDocument/2006/relationships">
+  <p:cSld>
+    <p:spTree>
+      <p:nvGrpSpPr>
+        <p:cNvPr id="1" name=""/>
+        <p:cNvGrpSpPr/>
+        <p:nvPr/>
+      </p:nvGrpSpPr>
+      <p:grpSpPr>
+        <a:xfrm>
+          <a:off x="0" y="0"/>
+          <a:ext cx="0" cy="0"/>
+          <a:chOff x="0" y="0"/>
+          <a:chExt cx="0" cy="0"/>
+        </a:xfrm>
+      </p:grpSpPr>
+      <p:sp>
+        <p:nvSpPr>
+          <p:cNvPr id="2" name="Slide Image Placeholder 1"/>
+          <p:cNvSpPr>
+            <a:spLocks noGrp="1"/>
+          </p:cNvSpPr>
+          <p:nvPr>
+            <p:ph type="sldImg" idx="2"/>
+          </p:nvPr>
+        </p:nvSpPr>
+        <p:spPr/>
+      </p:sp>
+      <p:sp>
+        <p:nvSpPr>
+          <p:cNvPr id="3" name="Notes Placeholder 2"/>
+          <p:cNvSpPr>
+            <a:spLocks noGrp="1"/>
+          </p:cNvSpPr>
+          <p:nvPr>
+            <p:ph type="body" idx="3" sz="quarter"/>
+          </p:nvPr>
+        </p:nvSpPr>
+        <p:spPr/>
+        <p:txBody>
+          <a:bodyPr/>
+          <a:lstStyle/>
+          <a:p>
+            <a:r>
+              <a:t>Take-home, three moves: 1) safety first, am I connected to myself; 2) hands on heart, how do you feel, listen; 3) tap when it's big, and with the waves, feel a little, come back, feel a little more.</a:t>
+            </a:r>
+          </a:p>
+        </p:txBody>
+      </p:sp>
+      <p:sp>
+        <p:nvSpPr>
+          <p:cNvPr id="4" name="Slide Number Placeholder 3"/>
+          <p:cNvSpPr>
+            <a:spLocks noGrp="1"/>
+          </p:cNvSpPr>
+          <p:nvPr>
+            <p:ph type="sldNum" idx="5" sz="quarter"/>
+          </p:nvPr>
+        </p:nvSpPr>
+        <p:spPr/>
+      </p:sp>
+    </p:spTree>
+  </p:cSld>
+  <p:clrMapOvr>
+    <a:masterClrMapping/>
+  </p:clrMapOvr>
+</p:notes>
+</file>
+
+<file path=ppt/notesSlides/notesSlide32.xml><?xml version="1.0" encoding="utf-8"?>
+<p:notes xmlns:a="http://schemas.openxmlformats.org/drawingml/2006/main" xmlns:p="http://schemas.openxmlformats.org/presentationml/2006/main" xmlns:r="http://schemas.openxmlformats.org/officeDocument/2006/relationships">
+  <p:cSld>
+    <p:spTree>
+      <p:nvGrpSpPr>
+        <p:cNvPr id="1" name=""/>
+        <p:cNvGrpSpPr/>
+        <p:nvPr/>
+      </p:nvGrpSpPr>
+      <p:grpSpPr>
+        <a:xfrm>
+          <a:off x="0" y="0"/>
+          <a:ext cx="0" cy="0"/>
+          <a:chOff x="0" y="0"/>
+          <a:chExt cx="0" cy="0"/>
+        </a:xfrm>
+      </p:grpSpPr>
+      <p:sp>
+        <p:nvSpPr>
+          <p:cNvPr id="2" name="Slide Image Placeholder 1"/>
+          <p:cNvSpPr>
+            <a:spLocks noGrp="1"/>
+          </p:cNvSpPr>
+          <p:nvPr>
+            <p:ph type="sldImg" idx="2"/>
+          </p:nvPr>
+        </p:nvSpPr>
+        <p:spPr/>
+      </p:sp>
+      <p:sp>
+        <p:nvSpPr>
+          <p:cNvPr id="3" name="Notes Placeholder 2"/>
+          <p:cNvSpPr>
+            <a:spLocks noGrp="1"/>
+          </p:cNvSpPr>
+          <p:nvPr>
+            <p:ph type="body" idx="3" sz="quarter"/>
+          </p:nvPr>
+        </p:nvSpPr>
+        <p:spPr/>
+        <p:txBody>
+          <a:bodyPr/>
+          <a:lstStyle/>
+          <a:p>
+            <a:r>
+              <a:t>Close: you don't master your emotions by controlling them, you master them by feeling safe enough to finally listen. Closing round, one line each: one feeling I'm going to stop numbing. Circle answers 'We hear you.' Blow out the candle.</a:t>
+            </a:r>
+          </a:p>
+        </p:txBody>
+      </p:sp>
+      <p:sp>
+        <p:nvSpPr>
+          <p:cNvPr id="4" name="Slide Number Placeholder 3"/>
+          <p:cNvSpPr>
+            <a:spLocks noGrp="1"/>
+          </p:cNvSpPr>
+          <p:nvPr>
+            <p:ph type="sldNum" idx="5" sz="quarter"/>
+          </p:nvPr>
+        </p:nvSpPr>
+        <p:spPr/>
+      </p:sp>
+    </p:spTree>
+  </p:cSld>
+  <p:clrMapOvr>
+    <a:masterClrMapping/>
+  </p:clrMapOvr>
+</p:notes>
+</file>
+
+<file path=ppt/notesSlides/notesSlide4.xml><?xml version="1.0" encoding="utf-8"?>
+<p:notes xmlns:a="http://schemas.openxmlformats.org/drawingml/2006/main" xmlns:p="http://schemas.openxmlformats.org/presentationml/2006/main" xmlns:r="http://schemas.openxmlformats.org/officeDocument/2006/relationships">
+  <p:cSld>
+    <p:spTree>
+      <p:nvGrpSpPr>
+        <p:cNvPr id="1" name=""/>
+        <p:cNvGrpSpPr/>
+        <p:nvPr/>
+      </p:nvGrpSpPr>
+      <p:grpSpPr>
+        <a:xfrm>
+          <a:off x="0" y="0"/>
+          <a:ext cx="0" cy="0"/>
+          <a:chOff x="0" y="0"/>
+          <a:chExt cx="0" cy="0"/>
+        </a:xfrm>
+      </p:grpSpPr>
+      <p:sp>
+        <p:nvSpPr>
+          <p:cNvPr id="2" name="Slide Image Placeholder 1"/>
+          <p:cNvSpPr>
+            <a:spLocks noGrp="1"/>
+          </p:cNvSpPr>
+          <p:nvPr>
+            <p:ph type="sldImg" idx="2"/>
+          </p:nvPr>
+        </p:nvSpPr>
+        <p:spPr/>
+      </p:sp>
+      <p:sp>
+        <p:nvSpPr>
+          <p:cNvPr id="3" name="Notes Placeholder 2"/>
+          <p:cNvSpPr>
+            <a:spLocks noGrp="1"/>
+          </p:cNvSpPr>
+          <p:nvPr>
+            <p:ph type="body" idx="3" sz="quarter"/>
+          </p:nvPr>
+        </p:nvSpPr>
+        <p:spPr/>
+        <p:txBody>
+          <a:bodyPr/>
+          <a:lstStyle/>
+          <a:p>
+            <a:r>
+              <a:t>Give your definition of safety, slowly: I'm connected to myself; I feel what's good for me; I test it out, one small step; I read how the other responds; then I choose, step forward or step away. Moving like that, connected, checking, choosing, there's no overwhelm.</a:t>
+            </a:r>
+          </a:p>
+        </p:txBody>
+      </p:sp>
+      <p:sp>
+        <p:nvSpPr>
+          <p:cNvPr id="4" name="Slide Number Placeholder 3"/>
+          <p:cNvSpPr>
+            <a:spLocks noGrp="1"/>
+          </p:cNvSpPr>
+          <p:nvPr>
+            <p:ph type="sldNum" idx="5" sz="quarter"/>
+          </p:nvPr>
+        </p:nvSpPr>
+        <p:spPr/>
+      </p:sp>
+    </p:spTree>
+  </p:cSld>
+  <p:clrMapOvr>
+    <a:masterClrMapping/>
+  </p:clrMapOvr>
+</p:notes>
+</file>
+
+<file path=ppt/notesSlides/notesSlide5.xml><?xml version="1.0" encoding="utf-8"?>
+<p:notes xmlns:a="http://schemas.openxmlformats.org/drawingml/2006/main" xmlns:p="http://schemas.openxmlformats.org/presentationml/2006/main" xmlns:r="http://schemas.openxmlformats.org/officeDocument/2006/relationships">
+  <p:cSld>
+    <p:spTree>
+      <p:nvGrpSpPr>
+        <p:cNvPr id="1" name=""/>
+        <p:cNvGrpSpPr/>
+        <p:nvPr/>
+      </p:nvGrpSpPr>
+      <p:grpSpPr>
+        <a:xfrm>
+          <a:off x="0" y="0"/>
+          <a:ext cx="0" cy="0"/>
+          <a:chOff x="0" y="0"/>
+          <a:chExt cx="0" cy="0"/>
+        </a:xfrm>
+      </p:grpSpPr>
+      <p:sp>
+        <p:nvSpPr>
+          <p:cNvPr id="2" name="Slide Image Placeholder 1"/>
+          <p:cNvSpPr>
+            <a:spLocks noGrp="1"/>
+          </p:cNvSpPr>
+          <p:nvPr>
+            <p:ph type="sldImg" idx="2"/>
+          </p:nvPr>
+        </p:nvSpPr>
+        <p:spPr/>
+      </p:sp>
+      <p:sp>
+        <p:nvSpPr>
+          <p:cNvPr id="3" name="Notes Placeholder 2"/>
+          <p:cNvSpPr>
+            <a:spLocks noGrp="1"/>
+          </p:cNvSpPr>
+          <p:nvPr>
+            <p:ph type="body" idx="3" sz="quarter"/>
+          </p:nvPr>
+        </p:nvSpPr>
+        <p:spPr/>
+        <p:txBody>
+          <a:bodyPr/>
+          <a:lstStyle/>
+          <a:p>
+            <a:r>
+              <a:t>Land it: when you stay with yourself the whole way, there's no overwhelm, because you never abandon yourself to cope.</a:t>
+            </a:r>
+          </a:p>
+        </p:txBody>
+      </p:sp>
+      <p:sp>
+        <p:nvSpPr>
+          <p:cNvPr id="4" name="Slide Number Placeholder 3"/>
+          <p:cNvSpPr>
+            <a:spLocks noGrp="1"/>
+          </p:cNvSpPr>
+          <p:nvPr>
+            <p:ph type="sldNum" idx="5" sz="quarter"/>
+          </p:nvPr>
+        </p:nvSpPr>
+        <p:spPr/>
+      </p:sp>
+    </p:spTree>
+  </p:cSld>
+  <p:clrMapOvr>
+    <a:masterClrMapping/>
+  </p:clrMapOvr>
+</p:notes>
+</file>
+
+<file path=ppt/notesSlides/notesSlide6.xml><?xml version="1.0" encoding="utf-8"?>
+<p:notes xmlns:a="http://schemas.openxmlformats.org/drawingml/2006/main" xmlns:p="http://schemas.openxmlformats.org/presentationml/2006/main" xmlns:r="http://schemas.openxmlformats.org/officeDocument/2006/relationships">
+  <p:cSld>
+    <p:spTree>
+      <p:nvGrpSpPr>
+        <p:cNvPr id="1" name=""/>
+        <p:cNvGrpSpPr/>
+        <p:nvPr/>
+      </p:nvGrpSpPr>
+      <p:grpSpPr>
+        <a:xfrm>
+          <a:off x="0" y="0"/>
+          <a:ext cx="0" cy="0"/>
+          <a:chOff x="0" y="0"/>
+          <a:chExt cx="0" cy="0"/>
+        </a:xfrm>
+      </p:grpSpPr>
+      <p:sp>
+        <p:nvSpPr>
+          <p:cNvPr id="2" name="Slide Image Placeholder 1"/>
+          <p:cNvSpPr>
+            <a:spLocks noGrp="1"/>
+          </p:cNvSpPr>
+          <p:nvPr>
+            <p:ph type="sldImg" idx="2"/>
+          </p:nvPr>
+        </p:nvSpPr>
+        <p:spPr/>
+      </p:sp>
+      <p:sp>
+        <p:nvSpPr>
+          <p:cNvPr id="3" name="Notes Placeholder 2"/>
+          <p:cNvSpPr>
+            <a:spLocks noGrp="1"/>
+          </p:cNvSpPr>
+          <p:nvPr>
+            <p:ph type="body" idx="3" sz="quarter"/>
+          </p:nvPr>
+        </p:nvSpPr>
+        <p:spPr/>
+        <p:txBody>
+          <a:bodyPr/>
+          <a:lstStyle/>
+          <a:p>
+            <a:r>
+              <a:t>Pose the reflection questions before the breakout: When do I feel safe? When do I not? Where do I abandon myself to keep the peace? What does it feel like in my body when I leave myself?</a:t>
+            </a:r>
+          </a:p>
+        </p:txBody>
+      </p:sp>
+      <p:sp>
+        <p:nvSpPr>
+          <p:cNvPr id="4" name="Slide Number Placeholder 3"/>
+          <p:cNvSpPr>
+            <a:spLocks noGrp="1"/>
+          </p:cNvSpPr>
+          <p:nvPr>
+            <p:ph type="sldNum" idx="5" sz="quarter"/>
+          </p:nvPr>
+        </p:nvSpPr>
+        <p:spPr/>
+      </p:sp>
+    </p:spTree>
+  </p:cSld>
+  <p:clrMapOvr>
+    <a:masterClrMapping/>
+  </p:clrMapOvr>
+</p:notes>
+</file>
+
+<file path=ppt/notesSlides/notesSlide7.xml><?xml version="1.0" encoding="utf-8"?>
+<p:notes xmlns:a="http://schemas.openxmlformats.org/drawingml/2006/main" xmlns:p="http://schemas.openxmlformats.org/presentationml/2006/main" xmlns:r="http://schemas.openxmlformats.org/officeDocument/2006/relationships">
+  <p:cSld>
+    <p:spTree>
+      <p:nvGrpSpPr>
+        <p:cNvPr id="1" name=""/>
+        <p:cNvGrpSpPr/>
+        <p:nvPr/>
+      </p:nvGrpSpPr>
+      <p:grpSpPr>
+        <a:xfrm>
+          <a:off x="0" y="0"/>
+          <a:ext cx="0" cy="0"/>
+          <a:chOff x="0" y="0"/>
+          <a:chExt cx="0" cy="0"/>
+        </a:xfrm>
+      </p:grpSpPr>
+      <p:sp>
+        <p:nvSpPr>
+          <p:cNvPr id="2" name="Slide Image Placeholder 1"/>
+          <p:cNvSpPr>
+            <a:spLocks noGrp="1"/>
+          </p:cNvSpPr>
+          <p:nvPr>
+            <p:ph type="sldImg" idx="2"/>
+          </p:nvPr>
+        </p:nvSpPr>
+        <p:spPr/>
+      </p:sp>
+      <p:sp>
+        <p:nvSpPr>
+          <p:cNvPr id="3" name="Notes Placeholder 2"/>
+          <p:cNvSpPr>
+            <a:spLocks noGrp="1"/>
+          </p:cNvSpPr>
+          <p:nvPr>
+            <p:ph type="body" idx="3" sz="quarter"/>
+          </p:nvPr>
+        </p:nvSpPr>
+        <p:spPr/>
+        <p:txBody>
+          <a:bodyPr/>
+          <a:lstStyle/>
+          <a:p>
+            <a:r>
+              <a:t>Broadcast to the rooms. In pairs, Partner A about 5-6 minutes: 'One place I feel safe is... one place I don't is...' then 'One way I abandon myself is...' and 'What it feels like in my body when I leave myself is...' Partner B witnesses, no fixing. Swap. Main-room: one way I abandon myself.</a:t>
+            </a:r>
+          </a:p>
+        </p:txBody>
+      </p:sp>
+      <p:sp>
+        <p:nvSpPr>
+          <p:cNvPr id="4" name="Slide Number Placeholder 3"/>
+          <p:cNvSpPr>
+            <a:spLocks noGrp="1"/>
+          </p:cNvSpPr>
+          <p:nvPr>
+            <p:ph type="sldNum" idx="5" sz="quarter"/>
+          </p:nvPr>
+        </p:nvSpPr>
+        <p:spPr/>
+      </p:sp>
+    </p:spTree>
+  </p:cSld>
+  <p:clrMapOvr>
+    <a:masterClrMapping/>
+  </p:clrMapOvr>
+</p:notes>
+</file>
+
+<file path=ppt/notesSlides/notesSlide8.xml><?xml version="1.0" encoding="utf-8"?>
+<p:notes xmlns:a="http://schemas.openxmlformats.org/drawingml/2006/main" xmlns:p="http://schemas.openxmlformats.org/presentationml/2006/main" xmlns:r="http://schemas.openxmlformats.org/officeDocument/2006/relationships">
+  <p:cSld>
+    <p:spTree>
+      <p:nvGrpSpPr>
+        <p:cNvPr id="1" name=""/>
+        <p:cNvGrpSpPr/>
+        <p:nvPr/>
+      </p:nvGrpSpPr>
+      <p:grpSpPr>
+        <a:xfrm>
+          <a:off x="0" y="0"/>
+          <a:ext cx="0" cy="0"/>
+          <a:chOff x="0" y="0"/>
+          <a:chExt cx="0" cy="0"/>
+        </a:xfrm>
+      </p:grpSpPr>
+      <p:sp>
+        <p:nvSpPr>
+          <p:cNvPr id="2" name="Slide Image Placeholder 1"/>
+          <p:cNvSpPr>
+            <a:spLocks noGrp="1"/>
+          </p:cNvSpPr>
+          <p:nvPr>
+            <p:ph type="sldImg" idx="2"/>
+          </p:nvPr>
+        </p:nvSpPr>
+        <p:spPr/>
+      </p:sp>
+      <p:sp>
+        <p:nvSpPr>
+          <p:cNvPr id="3" name="Notes Placeholder 2"/>
+          <p:cNvSpPr>
+            <a:spLocks noGrp="1"/>
+          </p:cNvSpPr>
+          <p:nvPr>
+            <p:ph type="body" idx="3" sz="quarter"/>
+          </p:nvPr>
+        </p:nvSpPr>
+        <p:spPr/>
+        <p:txBody>
+          <a:bodyPr/>
+          <a:lstStyle/>
+          <a:p>
+            <a:r>
+              <a:t>Teach the numbing loop: stress makes emotions, emotions make stress; we reach for something outside ourselves, food, wine, phone, busyness, other people's problems, to fill an emotional hole.</a:t>
+            </a:r>
+          </a:p>
+        </p:txBody>
+      </p:sp>
+      <p:sp>
+        <p:nvSpPr>
+          <p:cNvPr id="4" name="Slide Number Placeholder 3"/>
+          <p:cNvSpPr>
+            <a:spLocks noGrp="1"/>
+          </p:cNvSpPr>
+          <p:nvPr>
+            <p:ph type="sldNum" idx="5" sz="quarter"/>
+          </p:nvPr>
+        </p:nvSpPr>
+        <p:spPr/>
+      </p:sp>
+    </p:spTree>
+  </p:cSld>
+  <p:clrMapOvr>
+    <a:masterClrMapping/>
+  </p:clrMapOvr>
+</p:notes>
+</file>
+
+<file path=ppt/notesSlides/notesSlide9.xml><?xml version="1.0" encoding="utf-8"?>
+<p:notes xmlns:a="http://schemas.openxmlformats.org/drawingml/2006/main" xmlns:p="http://schemas.openxmlformats.org/presentationml/2006/main" xmlns:r="http://schemas.openxmlformats.org/officeDocument/2006/relationships">
+  <p:cSld>
+    <p:spTree>
+      <p:nvGrpSpPr>
+        <p:cNvPr id="1" name=""/>
+        <p:cNvGrpSpPr/>
+        <p:nvPr/>
+      </p:nvGrpSpPr>
+      <p:grpSpPr>
+        <a:xfrm>
+          <a:off x="0" y="0"/>
+          <a:ext cx="0" cy="0"/>
+          <a:chOff x="0" y="0"/>
+          <a:chExt cx="0" cy="0"/>
+        </a:xfrm>
+      </p:grpSpPr>
+      <p:sp>
+        <p:nvSpPr>
+          <p:cNvPr id="2" name="Slide Image Placeholder 1"/>
+          <p:cNvSpPr>
+            <a:spLocks noGrp="1"/>
+          </p:cNvSpPr>
+          <p:nvPr>
+            <p:ph type="sldImg" idx="2"/>
+          </p:nvPr>
+        </p:nvSpPr>
+        <p:spPr/>
+      </p:sp>
+      <p:sp>
+        <p:nvSpPr>
+          <p:cNvPr id="3" name="Notes Placeholder 2"/>
+          <p:cNvSpPr>
+            <a:spLocks noGrp="1"/>
+          </p:cNvSpPr>
+          <p:nvPr>
+            <p:ph type="body" idx="3" sz="quarter"/>
+          </p:nvPr>
+        </p:nvSpPr>
+        <p:spPr/>
+        <p:txBody>
+          <a:bodyPr/>
+          <a:lstStyle/>
+          <a:p>
+            <a:r>
+              <a:t>And it can't be filled from outside. There's no signal that says your emotional need is met, no leptin for feelings. So the fix backfires, we feel guilty, and the feeling still waits to be heard.</a:t>
+            </a:r>
+          </a:p>
+        </p:txBody>
+      </p:sp>
+      <p:sp>
+        <p:nvSpPr>
+          <p:cNvPr id="4" name="Slide Number Placeholder 3"/>
+          <p:cNvSpPr>
+            <a:spLocks noGrp="1"/>
+          </p:cNvSpPr>
+          <p:nvPr>
+            <p:ph type="sldNum" idx="5" sz="quarter"/>
+          </p:nvPr>
+        </p:nvSpPr>
+        <p:spPr/>
+      </p:sp>
+    </p:spTree>
+  </p:cSld>
+  <p:clrMapOvr>
+    <a:masterClrMapping/>
+  </p:clrMapOvr>
+</p:notes>
 </file>
 
 <file path=ppt/slideLayouts/slideLayout1.xml><?xml version="1.0" encoding="utf-8"?>
@@ -10013,4 +12603,324 @@
   </a:objectDefaults>
   <a:extraClrSchemeLst/>
 </a:theme>
+</file>
+
+<file path=ppt/theme/theme2.xml><?xml version="1.0" encoding="utf-8"?>
+<a:theme xmlns:a="http://schemas.openxmlformats.org/drawingml/2006/main" name="Office Theme">
+  <a:themeElements>
+    <a:clrScheme name="Office">
+      <a:dk1>
+        <a:sysClr val="windowText" lastClr="000000"/>
+      </a:dk1>
+      <a:lt1>
+        <a:sysClr val="window" lastClr="FFFFFF"/>
+      </a:lt1>
+      <a:dk2>
+        <a:srgbClr val="1F497D"/>
+      </a:dk2>
+      <a:lt2>
+        <a:srgbClr val="EEECE1"/>
+      </a:lt2>
+      <a:accent1>
+        <a:srgbClr val="4F81BD"/>
+      </a:accent1>
+      <a:accent2>
+        <a:srgbClr val="C0504D"/>
+      </a:accent2>
+      <a:accent3>
+        <a:srgbClr val="9BBB59"/>
+      </a:accent3>
+      <a:accent4>
+        <a:srgbClr val="8064A2"/>
+      </a:accent4>
+      <a:accent5>
+        <a:srgbClr val="4BACC6"/>
+      </a:accent5>
+      <a:accent6>
+        <a:srgbClr val="F79646"/>
+      </a:accent6>
+      <a:hlink>
+        <a:srgbClr val="0000FF"/>
+      </a:hlink>
+      <a:folHlink>
+        <a:srgbClr val="800080"/>
+      </a:folHlink>
+    </a:clrScheme>
+    <a:fontScheme name="Office">
+      <a:majorFont>
+        <a:latin typeface="Calibri"/>
+        <a:ea typeface=""/>
+        <a:cs typeface=""/>
+        <a:font script="Jpan" typeface="ＭＳ Ｐゴシック"/>
+        <a:font script="Hang" typeface="맑은 고딕"/>
+        <a:font script="Hans" typeface="宋体"/>
+        <a:font script="Hant" typeface="新細明體"/>
+        <a:font script="Arab" typeface="Times New Roman"/>
+        <a:font script="Hebr" typeface="Times New Roman"/>
+        <a:font script="Thai" typeface="Angsana New"/>
+        <a:font script="Ethi" typeface="Nyala"/>
+        <a:font script="Beng" typeface="Vrinda"/>
+        <a:font script="Gujr" typeface="Shruti"/>
+        <a:font script="Khmr" typeface="MoolBoran"/>
+        <a:font script="Knda" typeface="Tunga"/>
+        <a:font script="Guru" typeface="Raavi"/>
+        <a:font script="Cans" typeface="Euphemia"/>
+        <a:font script="Cher" typeface="Plantagenet Cherokee"/>
+        <a:font script="Yiii" typeface="Microsoft Yi Baiti"/>
+        <a:font script="Tibt" typeface="Microsoft Himalaya"/>
+        <a:font script="Thaa" typeface="MV Boli"/>
+        <a:font script="Deva" typeface="Mangal"/>
+        <a:font script="Telu" typeface="Gautami"/>
+        <a:font script="Taml" typeface="Latha"/>
+        <a:font script="Syrc" typeface="Estrangelo Edessa"/>
+        <a:font script="Orya" typeface="Kalinga"/>
+        <a:font script="Mlym" typeface="Kartika"/>
+        <a:font script="Laoo" typeface="DokChampa"/>
+        <a:font script="Sinh" typeface="Iskoola Pota"/>
+        <a:font script="Mong" typeface="Mongolian Baiti"/>
+        <a:font script="Viet" typeface="Times New Roman"/>
+        <a:font script="Uigh" typeface="Microsoft Uighur"/>
+        <a:font script="Geor" typeface="Sylfaen"/>
+      </a:majorFont>
+      <a:minorFont>
+        <a:latin typeface="Calibri"/>
+        <a:ea typeface=""/>
+        <a:cs typeface=""/>
+        <a:font script="Jpan" typeface="ＭＳ Ｐゴシック"/>
+        <a:font script="Hang" typeface="맑은 고딕"/>
+        <a:font script="Hans" typeface="宋体"/>
+        <a:font script="Hant" typeface="新細明體"/>
+        <a:font script="Arab" typeface="Arial"/>
+        <a:font script="Hebr" typeface="Arial"/>
+        <a:font script="Thai" typeface="Cordia New"/>
+        <a:font script="Ethi" typeface="Nyala"/>
+        <a:font script="Beng" typeface="Vrinda"/>
+        <a:font script="Gujr" typeface="Shruti"/>
+        <a:font script="Khmr" typeface="DaunPenh"/>
+        <a:font script="Knda" typeface="Tunga"/>
+        <a:font script="Guru" typeface="Raavi"/>
+        <a:font script="Cans" typeface="Euphemia"/>
+        <a:font script="Cher" typeface="Plantagenet Cherokee"/>
+        <a:font script="Yiii" typeface="Microsoft Yi Baiti"/>
+        <a:font script="Tibt" typeface="Microsoft Himalaya"/>
+        <a:font script="Thaa" typeface="MV Boli"/>
+        <a:font script="Deva" typeface="Mangal"/>
+        <a:font script="Telu" typeface="Gautami"/>
+        <a:font script="Taml" typeface="Latha"/>
+        <a:font script="Syrc" typeface="Estrangelo Edessa"/>
+        <a:font script="Orya" typeface="Kalinga"/>
+        <a:font script="Mlym" typeface="Kartika"/>
+        <a:font script="Laoo" typeface="DokChampa"/>
+        <a:font script="Sinh" typeface="Iskoola Pota"/>
+        <a:font script="Mong" typeface="Mongolian Baiti"/>
+        <a:font script="Viet" typeface="Arial"/>
+        <a:font script="Uigh" typeface="Microsoft Uighur"/>
+        <a:font script="Geor" typeface="Sylfaen"/>
+      </a:minorFont>
+    </a:fontScheme>
+    <a:fmtScheme name="Office">
+      <a:fillStyleLst>
+        <a:solidFill>
+          <a:schemeClr val="phClr"/>
+        </a:solidFill>
+        <a:gradFill rotWithShape="1">
+          <a:gsLst>
+            <a:gs pos="0">
+              <a:schemeClr val="phClr">
+                <a:tint val="50000"/>
+                <a:satMod val="300000"/>
+              </a:schemeClr>
+            </a:gs>
+            <a:gs pos="35000">
+              <a:schemeClr val="phClr">
+                <a:tint val="37000"/>
+                <a:satMod val="300000"/>
+              </a:schemeClr>
+            </a:gs>
+            <a:gs pos="100000">
+              <a:schemeClr val="phClr">
+                <a:tint val="15000"/>
+                <a:satMod val="350000"/>
+              </a:schemeClr>
+            </a:gs>
+          </a:gsLst>
+          <a:lin ang="16200000" scaled="1"/>
+        </a:gradFill>
+        <a:gradFill rotWithShape="1">
+          <a:gsLst>
+            <a:gs pos="0">
+              <a:schemeClr val="phClr">
+                <a:tint val="100000"/>
+                <a:shade val="100000"/>
+                <a:satMod val="130000"/>
+              </a:schemeClr>
+            </a:gs>
+            <a:gs pos="100000">
+              <a:schemeClr val="phClr">
+                <a:tint val="50000"/>
+                <a:shade val="100000"/>
+                <a:satMod val="350000"/>
+              </a:schemeClr>
+            </a:gs>
+          </a:gsLst>
+          <a:lin ang="16200000" scaled="0"/>
+        </a:gradFill>
+      </a:fillStyleLst>
+      <a:lnStyleLst>
+        <a:ln w="9525" cap="flat" cmpd="sng" algn="ctr">
+          <a:solidFill>
+            <a:schemeClr val="phClr">
+              <a:shade val="95000"/>
+              <a:satMod val="105000"/>
+            </a:schemeClr>
+          </a:solidFill>
+          <a:prstDash val="solid"/>
+        </a:ln>
+        <a:ln w="25400" cap="flat" cmpd="sng" algn="ctr">
+          <a:solidFill>
+            <a:schemeClr val="phClr"/>
+          </a:solidFill>
+          <a:prstDash val="solid"/>
+        </a:ln>
+        <a:ln w="38100" cap="flat" cmpd="sng" algn="ctr">
+          <a:solidFill>
+            <a:schemeClr val="phClr"/>
+          </a:solidFill>
+          <a:prstDash val="solid"/>
+        </a:ln>
+      </a:lnStyleLst>
+      <a:effectStyleLst>
+        <a:effectStyle>
+          <a:effectLst>
+            <a:outerShdw blurRad="40000" dist="20000" dir="5400000" rotWithShape="0">
+              <a:srgbClr val="000000">
+                <a:alpha val="38000"/>
+              </a:srgbClr>
+            </a:outerShdw>
+          </a:effectLst>
+        </a:effectStyle>
+        <a:effectStyle>
+          <a:effectLst>
+            <a:outerShdw blurRad="40000" dist="23000" dir="5400000" rotWithShape="0">
+              <a:srgbClr val="000000">
+                <a:alpha val="35000"/>
+              </a:srgbClr>
+            </a:outerShdw>
+          </a:effectLst>
+        </a:effectStyle>
+        <a:effectStyle>
+          <a:effectLst>
+            <a:outerShdw blurRad="40000" dist="23000" dir="5400000" rotWithShape="0">
+              <a:srgbClr val="000000">
+                <a:alpha val="35000"/>
+              </a:srgbClr>
+            </a:outerShdw>
+          </a:effectLst>
+          <a:scene3d>
+            <a:camera prst="orthographicFront">
+              <a:rot lat="0" lon="0" rev="0"/>
+            </a:camera>
+            <a:lightRig rig="threePt" dir="t">
+              <a:rot lat="0" lon="0" rev="1200000"/>
+            </a:lightRig>
+          </a:scene3d>
+          <a:sp3d>
+            <a:bevelT w="63500" h="25400"/>
+          </a:sp3d>
+        </a:effectStyle>
+      </a:effectStyleLst>
+      <a:bgFillStyleLst>
+        <a:solidFill>
+          <a:schemeClr val="phClr"/>
+        </a:solidFill>
+        <a:gradFill rotWithShape="1">
+          <a:gsLst>
+            <a:gs pos="0">
+              <a:schemeClr val="phClr">
+                <a:tint val="40000"/>
+                <a:satMod val="350000"/>
+              </a:schemeClr>
+            </a:gs>
+            <a:gs pos="40000">
+              <a:schemeClr val="phClr">
+                <a:tint val="45000"/>
+                <a:shade val="99000"/>
+                <a:satMod val="350000"/>
+              </a:schemeClr>
+            </a:gs>
+            <a:gs pos="100000">
+              <a:schemeClr val="phClr">
+                <a:shade val="20000"/>
+                <a:satMod val="255000"/>
+              </a:schemeClr>
+            </a:gs>
+          </a:gsLst>
+          <a:path path="circle">
+            <a:fillToRect l="50000" t="-80000" r="50000" b="180000"/>
+          </a:path>
+        </a:gradFill>
+        <a:gradFill rotWithShape="1">
+          <a:gsLst>
+            <a:gs pos="0">
+              <a:schemeClr val="phClr">
+                <a:tint val="80000"/>
+                <a:satMod val="300000"/>
+              </a:schemeClr>
+            </a:gs>
+            <a:gs pos="100000">
+              <a:schemeClr val="phClr">
+                <a:shade val="30000"/>
+                <a:satMod val="200000"/>
+              </a:schemeClr>
+            </a:gs>
+          </a:gsLst>
+          <a:path path="circle">
+            <a:fillToRect l="50000" t="50000" r="50000" b="50000"/>
+          </a:path>
+        </a:gradFill>
+      </a:bgFillStyleLst>
+    </a:fmtScheme>
+  </a:themeElements>
+  <a:objectDefaults>
+    <a:spDef>
+      <a:spPr/>
+      <a:bodyPr/>
+      <a:lstStyle/>
+      <a:style>
+        <a:lnRef idx="1">
+          <a:schemeClr val="accent1"/>
+        </a:lnRef>
+        <a:fillRef idx="3">
+          <a:schemeClr val="accent1"/>
+        </a:fillRef>
+        <a:effectRef idx="2">
+          <a:schemeClr val="accent1"/>
+        </a:effectRef>
+        <a:fontRef idx="minor">
+          <a:schemeClr val="lt1"/>
+        </a:fontRef>
+      </a:style>
+    </a:spDef>
+    <a:lnDef>
+      <a:spPr/>
+      <a:bodyPr/>
+      <a:lstStyle/>
+      <a:style>
+        <a:lnRef idx="2">
+          <a:schemeClr val="accent1"/>
+        </a:lnRef>
+        <a:fillRef idx="0">
+          <a:schemeClr val="accent1"/>
+        </a:fillRef>
+        <a:effectRef idx="1">
+          <a:schemeClr val="accent1"/>
+        </a:effectRef>
+        <a:fontRef idx="minor">
+          <a:schemeClr val="tx1"/>
+        </a:fontRef>
+      </a:style>
+    </a:lnDef>
+  </a:objectDefaults>
+  <a:extraClrSchemeLst/>
+</a:theme>
 </file>
</xml_diff>